<commit_message>
fix: update PPT searcher sections to two-mode architecture (DFPN/VCF + DefenseSearcher); fix BOARD_DIR path; regenerate 28-slide deck
</commit_message>
<xml_diff>
--- a/五子棋项目阶段汇报.pptx
+++ b/五子棋项目阶段汇报.pptx
@@ -669,7 +669,7 @@
           <a:lstStyle/>
           <a:p>
             <a:r>
-              <a:t>搜索器的输出是 CompactCertificate，三种节点：terminal 是胜利叶子，proverMove 是目标方选一个着法，opponentMoves 是列出对手全部应手。编号规则是父节点必须小于子节点，自环和回边一律拒绝。</a:t>
+              <a:t>搜索器有两种输出协议。模式 A 的 CompactCertificate 有三种节点：terminal 是胜利叶子，proverMove 是目标方选一个着法，opponentMoves 是列出对手全部应手。模式 B 的 DefenseCertificate 对应防守语义：terminal 叶子必须是防守方胜或和棋，defenderMove 是防守方选一个保持防守的着法，attackerMoves 是覆盖攻击方的全部合法应手，漏一个就整张被拒。编号规则都是父节点小于子节点，自环和回边一律拒绝。</a:t>
             </a:r>
           </a:p>
         </p:txBody>
@@ -739,7 +739,7 @@
           <a:lstStyle/>
           <a:p>
             <a:r>
-              <a:t>这是整个设计最核心的地方。左边这些——搜索算法、启发式、剪枝、缓存、C++ 预检——全部不可信，只生成候选。右边 Lean 检查器把每个节点重新检查：重算终局、验证合法着法、验证子局面、检查对手全覆盖，通过之后才得到 CanForceWin 定理。</a:t>
+              <a:t>这是整个设计最核心的地方。左边这些——搜索算法、启发式、剪枝、缓存、C++ 预检——全部不可信，只生成候选。右边 Lean 检查器把每个节点重新检查：checkCertificate 和 checkDefenseCertificateAt 重算终局、验证合法着法、验证子局面、检查攻击方全覆盖，通过之后才得到 CanForceWin 或 CanPreventWin 定理。</a:t>
             </a:r>
           </a:p>
         </p:txBody>
@@ -809,7 +809,7 @@
           <a:lstStyle/>
           <a:p>
             <a:r>
-              <a:t>验收按四步走。一步胜、两个应手、导出复检三步已经打通，证书都在 Lean 里复检通过；有限深度搜索有参考实现，但规模还比较有限。整体上框架是完整的。</a:t>
+              <a:t>验收按四步走。一步胜、两个应手、防御证书链和中盘和棋四步都已经打通：防御证书链包括 --prove 模式、DefenseCertificate 和 Lean 检查器，中盘和棋给出了 9 个机器验证的 StandardDraw 局面。整体上框架是完整的。</a:t>
             </a:r>
           </a:p>
         </p:txBody>
@@ -2209,7 +2209,7 @@
           <a:lstStyle/>
           <a:p>
             <a:r>
-              <a:t>搜索器用 C++ 实现：输入局面后，DFPN 主搜索负责证明数搜索，VCF 快攻负责连续冲四检测，产出候选证书，再导出成 Lean 源码。中间还有置换表、迭代加深、资源上限这些组件。注意：整条流水线产出的都只是候选数据。</a:t>
+              <a:t>搜索器用 C++ 实现，有两条流水线。模式 A 是强制胜搜索：输入局面后，DFPN 主搜索负责证明数搜索，VCF 快攻负责连续冲四检测，产出 CompactCertificate 候选证书，再导出成 Lean 源码。模式 B 是防守证明：用 DefenseSearcher 做完整 AND/OR 搜索，目标是对给定的攻击方证明防守方能阻止其获胜，状态严格区分 found、refuted 和 unknown，产出 DefenseCertificate。两条流水线都有置换表、迭代加深、资源上限等组件，产出的都只是候选数据。</a:t>
             </a:r>
           </a:p>
         </p:txBody>
@@ -7980,7 +7980,7 @@
                 <a:latin typeface="微软雅黑"/>
                 <a:ea typeface="微软雅黑"/>
               </a:rPr>
-              <a:t>输出协议：CompactCertificate</a:t>
+              <a:t>输出协议：两种证书</a:t>
             </a:r>
           </a:p>
         </p:txBody>
@@ -8016,21 +8016,77 @@
                 <a:latin typeface="微软雅黑"/>
                 <a:ea typeface="微软雅黑"/>
               </a:rPr>
-              <a:t>Output</a:t>
-            </a:r>
-          </a:p>
-        </p:txBody>
-      </p:sp>
-      <p:sp>
-        <p:nvSpPr>
-          <p:cNvPr id="6" name="Rectangle 5"/>
+              <a:t>Output · v1</a:t>
+            </a:r>
+          </a:p>
+        </p:txBody>
+      </p:sp>
+      <p:sp>
+        <p:nvSpPr>
+          <p:cNvPr id="6" name="Rounded Rectangle 5"/>
           <p:cNvSpPr/>
           <p:nvPr/>
         </p:nvSpPr>
         <p:spPr>
           <a:xfrm>
-            <a:off x="566928" y="1508760"/>
-            <a:ext cx="3593592" cy="713232"/>
+            <a:off x="566928" y="1188720"/>
+            <a:ext cx="11055096" cy="502920"/>
+          </a:xfrm>
+          <a:prstGeom prst="roundRect">
+            <a:avLst>
+              <a:gd name="adj" fmla="val 12000"/>
+            </a:avLst>
+          </a:prstGeom>
+          <a:solidFill>
+            <a:srgbClr val="1B2A4A"/>
+          </a:solidFill>
+          <a:ln>
+            <a:noFill/>
+          </a:ln>
+          <a:effectLst/>
+        </p:spPr>
+        <p:style>
+          <a:lnRef idx="1">
+            <a:schemeClr val="accent1"/>
+          </a:lnRef>
+          <a:fillRef idx="3">
+            <a:schemeClr val="accent1"/>
+          </a:fillRef>
+          <a:effectRef idx="2">
+            <a:schemeClr val="accent1"/>
+          </a:effectRef>
+          <a:fontRef idx="minor">
+            <a:schemeClr val="lt1"/>
+          </a:fontRef>
+        </p:style>
+        <p:txBody>
+          <a:bodyPr rtlCol="0" anchor="ctr" wrap="square" lIns="73152" rIns="73152" tIns="36576" bIns="36576"/>
+          <a:lstStyle/>
+          <a:p>
+            <a:pPr algn="ctr"/>
+            <a:r>
+              <a:rPr sz="1500" b="1">
+                <a:solidFill>
+                  <a:srgbClr val="FFFFFF"/>
+                </a:solidFill>
+                <a:latin typeface="微软雅黑"/>
+                <a:ea typeface="微软雅黑"/>
+              </a:rPr>
+              <a:t>模式 A · CompactCertificate（强制胜）</a:t>
+            </a:r>
+          </a:p>
+        </p:txBody>
+      </p:sp>
+      <p:sp>
+        <p:nvSpPr>
+          <p:cNvPr id="7" name="Rectangle 6"/>
+          <p:cNvSpPr/>
+          <p:nvPr/>
+        </p:nvSpPr>
+        <p:spPr>
+          <a:xfrm>
+            <a:off x="566928" y="1783080"/>
+            <a:ext cx="3593592" cy="566928"/>
           </a:xfrm>
           <a:prstGeom prst="rect">
             <a:avLst/>
@@ -8067,14 +8123,14 @@
       </p:sp>
       <p:sp>
         <p:nvSpPr>
-          <p:cNvPr id="7" name="TextBox 6"/>
+          <p:cNvPr id="8" name="TextBox 7"/>
           <p:cNvSpPr txBox="1"/>
           <p:nvPr/>
         </p:nvSpPr>
         <p:spPr>
           <a:xfrm>
-            <a:off x="841247" y="1508760"/>
-            <a:ext cx="2103120" cy="713232"/>
+            <a:off x="841247" y="1783080"/>
+            <a:ext cx="2103120" cy="566928"/>
           </a:xfrm>
           <a:prstGeom prst="rect">
             <a:avLst/>
@@ -8089,7 +8145,7 @@
           <a:p>
             <a:pPr algn="l"/>
             <a:r>
-              <a:rPr sz="1800" b="1">
+              <a:rPr sz="1700" b="1">
                 <a:solidFill>
                   <a:srgbClr val="FFFFFF"/>
                 </a:solidFill>
@@ -8103,14 +8159,14 @@
       </p:sp>
       <p:sp>
         <p:nvSpPr>
-          <p:cNvPr id="8" name="TextBox 7"/>
+          <p:cNvPr id="9" name="TextBox 8"/>
           <p:cNvSpPr txBox="1"/>
           <p:nvPr/>
         </p:nvSpPr>
         <p:spPr>
           <a:xfrm>
-            <a:off x="2395728" y="1508760"/>
-            <a:ext cx="1737360" cy="713232"/>
+            <a:off x="2395728" y="1783080"/>
+            <a:ext cx="1737360" cy="566928"/>
           </a:xfrm>
           <a:prstGeom prst="rect">
             <a:avLst/>
@@ -8125,7 +8181,7 @@
           <a:p>
             <a:pPr algn="r"/>
             <a:r>
-              <a:rPr sz="1350" b="0">
+              <a:rPr sz="1300" b="0">
                 <a:solidFill>
                   <a:srgbClr val="FFFFFF"/>
                 </a:solidFill>
@@ -8139,14 +8195,14 @@
       </p:sp>
       <p:sp>
         <p:nvSpPr>
-          <p:cNvPr id="9" name="Rounded Rectangle 8"/>
+          <p:cNvPr id="10" name="Rounded Rectangle 9"/>
           <p:cNvSpPr/>
           <p:nvPr/>
         </p:nvSpPr>
         <p:spPr>
           <a:xfrm>
-            <a:off x="566928" y="2221992"/>
-            <a:ext cx="3593592" cy="2514600"/>
+            <a:off x="566928" y="2350008"/>
+            <a:ext cx="3593592" cy="1417320"/>
           </a:xfrm>
           <a:prstGeom prst="roundRect">
             <a:avLst>
@@ -8185,7 +8241,7 @@
       </p:sp>
       <p:sp>
         <p:nvSpPr>
-          <p:cNvPr id="10" name="Rectangle 9"/>
+          <p:cNvPr id="11" name="Rectangle 10"/>
           <p:cNvSpPr/>
           <p:nvPr/>
         </p:nvSpPr>
@@ -8229,14 +8285,14 @@
       </p:sp>
       <p:sp>
         <p:nvSpPr>
-          <p:cNvPr id="11" name="TextBox 10"/>
+          <p:cNvPr id="12" name="TextBox 11"/>
           <p:cNvSpPr txBox="1"/>
           <p:nvPr/>
         </p:nvSpPr>
         <p:spPr>
           <a:xfrm>
             <a:off x="1170432" y="2542032"/>
-            <a:ext cx="2788920" cy="640080"/>
+            <a:ext cx="2788920" cy="365760"/>
           </a:xfrm>
           <a:prstGeom prst="rect">
             <a:avLst/>
@@ -8249,13 +8305,9 @@
           </a:bodyPr>
           <a:lstStyle/>
           <a:p>
-            <a:pPr algn="l">
-              <a:lnSpc>
-                <a:spcPct val="115000"/>
-              </a:lnSpc>
-            </a:pPr>
-            <a:r>
-              <a:rPr sz="1550" b="0">
+            <a:pPr algn="l"/>
+            <a:r>
+              <a:rPr sz="1350" b="0">
                 <a:solidFill>
                   <a:srgbClr val="2B2B2B"/>
                 </a:solidFill>
@@ -8269,13 +8321,13 @@
       </p:sp>
       <p:sp>
         <p:nvSpPr>
-          <p:cNvPr id="12" name="Rectangle 11"/>
+          <p:cNvPr id="13" name="Rectangle 12"/>
           <p:cNvSpPr/>
           <p:nvPr/>
         </p:nvSpPr>
         <p:spPr>
           <a:xfrm>
-            <a:off x="886968" y="3291840"/>
+            <a:off x="886968" y="2990088"/>
             <a:ext cx="137160" cy="137160"/>
           </a:xfrm>
           <a:prstGeom prst="rect">
@@ -8313,14 +8365,14 @@
       </p:sp>
       <p:sp>
         <p:nvSpPr>
-          <p:cNvPr id="13" name="TextBox 12"/>
+          <p:cNvPr id="14" name="TextBox 13"/>
           <p:cNvSpPr txBox="1"/>
           <p:nvPr/>
         </p:nvSpPr>
         <p:spPr>
           <a:xfrm>
-            <a:off x="1170432" y="3227832"/>
-            <a:ext cx="2788920" cy="640080"/>
+            <a:off x="1170432" y="2926079"/>
+            <a:ext cx="2788920" cy="365760"/>
           </a:xfrm>
           <a:prstGeom prst="rect">
             <a:avLst/>
@@ -8333,13 +8385,9 @@
           </a:bodyPr>
           <a:lstStyle/>
           <a:p>
-            <a:pPr algn="l">
-              <a:lnSpc>
-                <a:spcPct val="115000"/>
-              </a:lnSpc>
-            </a:pPr>
-            <a:r>
-              <a:rPr sz="1550" b="0">
+            <a:pPr algn="l"/>
+            <a:r>
+              <a:rPr sz="1350" b="0">
                 <a:solidFill>
                   <a:srgbClr val="2B2B2B"/>
                 </a:solidFill>
@@ -8353,13 +8401,13 @@
       </p:sp>
       <p:sp>
         <p:nvSpPr>
-          <p:cNvPr id="14" name="Rectangle 13"/>
+          <p:cNvPr id="15" name="Rectangle 14"/>
           <p:cNvSpPr/>
           <p:nvPr/>
         </p:nvSpPr>
         <p:spPr>
           <a:xfrm>
-            <a:off x="886968" y="3977639"/>
+            <a:off x="886968" y="3374136"/>
             <a:ext cx="137160" cy="137160"/>
           </a:xfrm>
           <a:prstGeom prst="rect">
@@ -8397,14 +8445,14 @@
       </p:sp>
       <p:sp>
         <p:nvSpPr>
-          <p:cNvPr id="15" name="TextBox 14"/>
+          <p:cNvPr id="16" name="TextBox 15"/>
           <p:cNvSpPr txBox="1"/>
           <p:nvPr/>
         </p:nvSpPr>
         <p:spPr>
           <a:xfrm>
-            <a:off x="1170432" y="3913631"/>
-            <a:ext cx="2788920" cy="640080"/>
+            <a:off x="1170432" y="3310127"/>
+            <a:ext cx="2788920" cy="365760"/>
           </a:xfrm>
           <a:prstGeom prst="rect">
             <a:avLst/>
@@ -8417,13 +8465,9 @@
           </a:bodyPr>
           <a:lstStyle/>
           <a:p>
-            <a:pPr algn="l">
-              <a:lnSpc>
-                <a:spcPct val="115000"/>
-              </a:lnSpc>
-            </a:pPr>
-            <a:r>
-              <a:rPr sz="1550" b="0">
+            <a:pPr algn="l"/>
+            <a:r>
+              <a:rPr sz="1350" b="0">
                 <a:solidFill>
                   <a:srgbClr val="2B2B2B"/>
                 </a:solidFill>
@@ -8437,14 +8481,14 @@
       </p:sp>
       <p:sp>
         <p:nvSpPr>
-          <p:cNvPr id="16" name="Rectangle 15"/>
+          <p:cNvPr id="17" name="Rectangle 16"/>
           <p:cNvSpPr/>
           <p:nvPr/>
         </p:nvSpPr>
         <p:spPr>
           <a:xfrm>
-            <a:off x="4343400" y="1508760"/>
-            <a:ext cx="3593592" cy="713232"/>
+            <a:off x="4343400" y="1783080"/>
+            <a:ext cx="3593592" cy="566928"/>
           </a:xfrm>
           <a:prstGeom prst="rect">
             <a:avLst/>
@@ -8481,14 +8525,14 @@
       </p:sp>
       <p:sp>
         <p:nvSpPr>
-          <p:cNvPr id="17" name="TextBox 16"/>
+          <p:cNvPr id="18" name="TextBox 17"/>
           <p:cNvSpPr txBox="1"/>
           <p:nvPr/>
         </p:nvSpPr>
         <p:spPr>
           <a:xfrm>
-            <a:off x="4617720" y="1508760"/>
-            <a:ext cx="2103120" cy="713232"/>
+            <a:off x="4617720" y="1783080"/>
+            <a:ext cx="2103120" cy="566928"/>
           </a:xfrm>
           <a:prstGeom prst="rect">
             <a:avLst/>
@@ -8503,7 +8547,7 @@
           <a:p>
             <a:pPr algn="l"/>
             <a:r>
-              <a:rPr sz="1800" b="1">
+              <a:rPr sz="1700" b="1">
                 <a:solidFill>
                   <a:srgbClr val="FFFFFF"/>
                 </a:solidFill>
@@ -8517,14 +8561,14 @@
       </p:sp>
       <p:sp>
         <p:nvSpPr>
-          <p:cNvPr id="18" name="TextBox 17"/>
+          <p:cNvPr id="19" name="TextBox 18"/>
           <p:cNvSpPr txBox="1"/>
           <p:nvPr/>
         </p:nvSpPr>
         <p:spPr>
           <a:xfrm>
-            <a:off x="6172200" y="1508760"/>
-            <a:ext cx="1737360" cy="713232"/>
+            <a:off x="6172200" y="1783080"/>
+            <a:ext cx="1737360" cy="566928"/>
           </a:xfrm>
           <a:prstGeom prst="rect">
             <a:avLst/>
@@ -8539,7 +8583,7 @@
           <a:p>
             <a:pPr algn="r"/>
             <a:r>
-              <a:rPr sz="1350" b="0">
+              <a:rPr sz="1300" b="0">
                 <a:solidFill>
                   <a:srgbClr val="FFFFFF"/>
                 </a:solidFill>
@@ -8553,14 +8597,14 @@
       </p:sp>
       <p:sp>
         <p:nvSpPr>
-          <p:cNvPr id="19" name="Rounded Rectangle 18"/>
+          <p:cNvPr id="20" name="Rounded Rectangle 19"/>
           <p:cNvSpPr/>
           <p:nvPr/>
         </p:nvSpPr>
         <p:spPr>
           <a:xfrm>
-            <a:off x="4343400" y="2221992"/>
-            <a:ext cx="3593592" cy="2514600"/>
+            <a:off x="4343400" y="2350008"/>
+            <a:ext cx="3593592" cy="1417320"/>
           </a:xfrm>
           <a:prstGeom prst="roundRect">
             <a:avLst>
@@ -8599,7 +8643,7 @@
       </p:sp>
       <p:sp>
         <p:nvSpPr>
-          <p:cNvPr id="20" name="Rectangle 19"/>
+          <p:cNvPr id="21" name="Rectangle 20"/>
           <p:cNvSpPr/>
           <p:nvPr/>
         </p:nvSpPr>
@@ -8643,14 +8687,14 @@
       </p:sp>
       <p:sp>
         <p:nvSpPr>
-          <p:cNvPr id="21" name="TextBox 20"/>
+          <p:cNvPr id="22" name="TextBox 21"/>
           <p:cNvSpPr txBox="1"/>
           <p:nvPr/>
         </p:nvSpPr>
         <p:spPr>
           <a:xfrm>
             <a:off x="4946904" y="2542032"/>
-            <a:ext cx="2788920" cy="640080"/>
+            <a:ext cx="2788920" cy="365760"/>
           </a:xfrm>
           <a:prstGeom prst="rect">
             <a:avLst/>
@@ -8663,13 +8707,9 @@
           </a:bodyPr>
           <a:lstStyle/>
           <a:p>
-            <a:pPr algn="l">
-              <a:lnSpc>
-                <a:spcPct val="115000"/>
-              </a:lnSpc>
-            </a:pPr>
-            <a:r>
-              <a:rPr sz="1550" b="0">
+            <a:pPr algn="l"/>
+            <a:r>
+              <a:rPr sz="1350" b="0">
                 <a:solidFill>
                   <a:srgbClr val="2B2B2B"/>
                 </a:solidFill>
@@ -8683,13 +8723,13 @@
       </p:sp>
       <p:sp>
         <p:nvSpPr>
-          <p:cNvPr id="22" name="Rectangle 21"/>
+          <p:cNvPr id="23" name="Rectangle 22"/>
           <p:cNvSpPr/>
           <p:nvPr/>
         </p:nvSpPr>
         <p:spPr>
           <a:xfrm>
-            <a:off x="4663440" y="3291840"/>
+            <a:off x="4663440" y="2990088"/>
             <a:ext cx="137160" cy="137160"/>
           </a:xfrm>
           <a:prstGeom prst="rect">
@@ -8727,14 +8767,14 @@
       </p:sp>
       <p:sp>
         <p:nvSpPr>
-          <p:cNvPr id="23" name="TextBox 22"/>
+          <p:cNvPr id="24" name="TextBox 23"/>
           <p:cNvSpPr txBox="1"/>
           <p:nvPr/>
         </p:nvSpPr>
         <p:spPr>
           <a:xfrm>
-            <a:off x="4946904" y="3227832"/>
-            <a:ext cx="2788920" cy="640080"/>
+            <a:off x="4946904" y="2926079"/>
+            <a:ext cx="2788920" cy="365760"/>
           </a:xfrm>
           <a:prstGeom prst="rect">
             <a:avLst/>
@@ -8747,13 +8787,9 @@
           </a:bodyPr>
           <a:lstStyle/>
           <a:p>
-            <a:pPr algn="l">
-              <a:lnSpc>
-                <a:spcPct val="115000"/>
-              </a:lnSpc>
-            </a:pPr>
-            <a:r>
-              <a:rPr sz="1550" b="0">
+            <a:pPr algn="l"/>
+            <a:r>
+              <a:rPr sz="1350" b="0">
                 <a:solidFill>
                   <a:srgbClr val="2B2B2B"/>
                 </a:solidFill>
@@ -8767,13 +8803,13 @@
       </p:sp>
       <p:sp>
         <p:nvSpPr>
-          <p:cNvPr id="24" name="Rectangle 23"/>
+          <p:cNvPr id="25" name="Rectangle 24"/>
           <p:cNvSpPr/>
           <p:nvPr/>
         </p:nvSpPr>
         <p:spPr>
           <a:xfrm>
-            <a:off x="4663440" y="3977639"/>
+            <a:off x="4663440" y="3374136"/>
             <a:ext cx="137160" cy="137160"/>
           </a:xfrm>
           <a:prstGeom prst="rect">
@@ -8811,14 +8847,14 @@
       </p:sp>
       <p:sp>
         <p:nvSpPr>
-          <p:cNvPr id="25" name="TextBox 24"/>
+          <p:cNvPr id="26" name="TextBox 25"/>
           <p:cNvSpPr txBox="1"/>
           <p:nvPr/>
         </p:nvSpPr>
         <p:spPr>
           <a:xfrm>
-            <a:off x="4946904" y="3913631"/>
-            <a:ext cx="2788920" cy="640080"/>
+            <a:off x="4946904" y="3310127"/>
+            <a:ext cx="2788920" cy="365760"/>
           </a:xfrm>
           <a:prstGeom prst="rect">
             <a:avLst/>
@@ -8831,13 +8867,9 @@
           </a:bodyPr>
           <a:lstStyle/>
           <a:p>
-            <a:pPr algn="l">
-              <a:lnSpc>
-                <a:spcPct val="115000"/>
-              </a:lnSpc>
-            </a:pPr>
-            <a:r>
-              <a:rPr sz="1550" b="0">
+            <a:pPr algn="l"/>
+            <a:r>
+              <a:rPr sz="1350" b="0">
                 <a:solidFill>
                   <a:srgbClr val="2B2B2B"/>
                 </a:solidFill>
@@ -8851,14 +8883,14 @@
       </p:sp>
       <p:sp>
         <p:nvSpPr>
-          <p:cNvPr id="26" name="Rectangle 25"/>
+          <p:cNvPr id="27" name="Rectangle 26"/>
           <p:cNvSpPr/>
           <p:nvPr/>
         </p:nvSpPr>
         <p:spPr>
           <a:xfrm>
-            <a:off x="8119871" y="1508760"/>
-            <a:ext cx="3593592" cy="713232"/>
+            <a:off x="8119871" y="1783080"/>
+            <a:ext cx="3593592" cy="566928"/>
           </a:xfrm>
           <a:prstGeom prst="rect">
             <a:avLst/>
@@ -8895,14 +8927,14 @@
       </p:sp>
       <p:sp>
         <p:nvSpPr>
-          <p:cNvPr id="27" name="TextBox 26"/>
+          <p:cNvPr id="28" name="TextBox 27"/>
           <p:cNvSpPr txBox="1"/>
           <p:nvPr/>
         </p:nvSpPr>
         <p:spPr>
           <a:xfrm>
-            <a:off x="8394192" y="1508760"/>
-            <a:ext cx="2103120" cy="713232"/>
+            <a:off x="8394192" y="1783080"/>
+            <a:ext cx="2103120" cy="566928"/>
           </a:xfrm>
           <a:prstGeom prst="rect">
             <a:avLst/>
@@ -8917,7 +8949,7 @@
           <a:p>
             <a:pPr algn="l"/>
             <a:r>
-              <a:rPr sz="1800" b="1">
+              <a:rPr sz="1700" b="1">
                 <a:solidFill>
                   <a:srgbClr val="FFFFFF"/>
                 </a:solidFill>
@@ -8931,14 +8963,14 @@
       </p:sp>
       <p:sp>
         <p:nvSpPr>
-          <p:cNvPr id="28" name="TextBox 27"/>
+          <p:cNvPr id="29" name="TextBox 28"/>
           <p:cNvSpPr txBox="1"/>
           <p:nvPr/>
         </p:nvSpPr>
         <p:spPr>
           <a:xfrm>
-            <a:off x="9948672" y="1508760"/>
-            <a:ext cx="1737360" cy="713232"/>
+            <a:off x="9948672" y="1783080"/>
+            <a:ext cx="1737360" cy="566928"/>
           </a:xfrm>
           <a:prstGeom prst="rect">
             <a:avLst/>
@@ -8953,7 +8985,7 @@
           <a:p>
             <a:pPr algn="r"/>
             <a:r>
-              <a:rPr sz="1350" b="0">
+              <a:rPr sz="1300" b="0">
                 <a:solidFill>
                   <a:srgbClr val="FFFFFF"/>
                 </a:solidFill>
@@ -8967,14 +8999,14 @@
       </p:sp>
       <p:sp>
         <p:nvSpPr>
-          <p:cNvPr id="29" name="Rounded Rectangle 28"/>
+          <p:cNvPr id="30" name="Rounded Rectangle 29"/>
           <p:cNvSpPr/>
           <p:nvPr/>
         </p:nvSpPr>
         <p:spPr>
           <a:xfrm>
-            <a:off x="8119871" y="2221992"/>
-            <a:ext cx="3593592" cy="2514600"/>
+            <a:off x="8119871" y="2350008"/>
+            <a:ext cx="3593592" cy="1417320"/>
           </a:xfrm>
           <a:prstGeom prst="roundRect">
             <a:avLst>
@@ -9013,7 +9045,7 @@
       </p:sp>
       <p:sp>
         <p:nvSpPr>
-          <p:cNvPr id="30" name="Rectangle 29"/>
+          <p:cNvPr id="31" name="Rectangle 30"/>
           <p:cNvSpPr/>
           <p:nvPr/>
         </p:nvSpPr>
@@ -9057,14 +9089,14 @@
       </p:sp>
       <p:sp>
         <p:nvSpPr>
-          <p:cNvPr id="31" name="TextBox 30"/>
+          <p:cNvPr id="32" name="TextBox 31"/>
           <p:cNvSpPr txBox="1"/>
           <p:nvPr/>
         </p:nvSpPr>
         <p:spPr>
           <a:xfrm>
             <a:off x="8723376" y="2542032"/>
-            <a:ext cx="2788920" cy="640080"/>
+            <a:ext cx="2788920" cy="365760"/>
           </a:xfrm>
           <a:prstGeom prst="rect">
             <a:avLst/>
@@ -9077,13 +9109,9 @@
           </a:bodyPr>
           <a:lstStyle/>
           <a:p>
-            <a:pPr algn="l">
-              <a:lnSpc>
-                <a:spcPct val="115000"/>
-              </a:lnSpc>
-            </a:pPr>
-            <a:r>
-              <a:rPr sz="1550" b="0">
+            <a:pPr algn="l"/>
+            <a:r>
+              <a:rPr sz="1350" b="0">
                 <a:solidFill>
                   <a:srgbClr val="2B2B2B"/>
                 </a:solidFill>
@@ -9097,13 +9125,13 @@
       </p:sp>
       <p:sp>
         <p:nvSpPr>
-          <p:cNvPr id="32" name="Rectangle 31"/>
+          <p:cNvPr id="33" name="Rectangle 32"/>
           <p:cNvSpPr/>
           <p:nvPr/>
         </p:nvSpPr>
         <p:spPr>
           <a:xfrm>
-            <a:off x="8439911" y="3291840"/>
+            <a:off x="8439911" y="2990088"/>
             <a:ext cx="137160" cy="137160"/>
           </a:xfrm>
           <a:prstGeom prst="rect">
@@ -9141,14 +9169,14 @@
       </p:sp>
       <p:sp>
         <p:nvSpPr>
-          <p:cNvPr id="33" name="TextBox 32"/>
+          <p:cNvPr id="34" name="TextBox 33"/>
           <p:cNvSpPr txBox="1"/>
           <p:nvPr/>
         </p:nvSpPr>
         <p:spPr>
           <a:xfrm>
-            <a:off x="8723376" y="3227832"/>
-            <a:ext cx="2788920" cy="640080"/>
+            <a:off x="8723376" y="2926079"/>
+            <a:ext cx="2788920" cy="365760"/>
           </a:xfrm>
           <a:prstGeom prst="rect">
             <a:avLst/>
@@ -9161,13 +9189,9 @@
           </a:bodyPr>
           <a:lstStyle/>
           <a:p>
-            <a:pPr algn="l">
-              <a:lnSpc>
-                <a:spcPct val="115000"/>
-              </a:lnSpc>
-            </a:pPr>
-            <a:r>
-              <a:rPr sz="1550" b="0">
+            <a:pPr algn="l"/>
+            <a:r>
+              <a:rPr sz="1350" b="0">
                 <a:solidFill>
                   <a:srgbClr val="2B2B2B"/>
                 </a:solidFill>
@@ -9181,13 +9205,13 @@
       </p:sp>
       <p:sp>
         <p:nvSpPr>
-          <p:cNvPr id="34" name="Rectangle 33"/>
+          <p:cNvPr id="35" name="Rectangle 34"/>
           <p:cNvSpPr/>
           <p:nvPr/>
         </p:nvSpPr>
         <p:spPr>
           <a:xfrm>
-            <a:off x="8439911" y="3977639"/>
+            <a:off x="8439911" y="3374136"/>
             <a:ext cx="137160" cy="137160"/>
           </a:xfrm>
           <a:prstGeom prst="rect">
@@ -9225,14 +9249,14 @@
       </p:sp>
       <p:sp>
         <p:nvSpPr>
-          <p:cNvPr id="35" name="TextBox 34"/>
+          <p:cNvPr id="36" name="TextBox 35"/>
           <p:cNvSpPr txBox="1"/>
           <p:nvPr/>
         </p:nvSpPr>
         <p:spPr>
           <a:xfrm>
-            <a:off x="8723376" y="3913631"/>
-            <a:ext cx="2788920" cy="640080"/>
+            <a:off x="8723376" y="3310127"/>
+            <a:ext cx="2788920" cy="365760"/>
           </a:xfrm>
           <a:prstGeom prst="rect">
             <a:avLst/>
@@ -9245,13 +9269,9 @@
           </a:bodyPr>
           <a:lstStyle/>
           <a:p>
-            <a:pPr algn="l">
-              <a:lnSpc>
-                <a:spcPct val="115000"/>
-              </a:lnSpc>
-            </a:pPr>
-            <a:r>
-              <a:rPr sz="1550" b="0">
+            <a:pPr algn="l"/>
+            <a:r>
+              <a:rPr sz="1350" b="0">
                 <a:solidFill>
                   <a:srgbClr val="2B2B2B"/>
                 </a:solidFill>
@@ -9265,14 +9285,1036 @@
       </p:sp>
       <p:sp>
         <p:nvSpPr>
-          <p:cNvPr id="36" name="Rounded Rectangle 35"/>
+          <p:cNvPr id="37" name="Rounded Rectangle 36"/>
           <p:cNvSpPr/>
           <p:nvPr/>
         </p:nvSpPr>
         <p:spPr>
           <a:xfrm>
-            <a:off x="566928" y="5029200"/>
-            <a:ext cx="11055096" cy="777240"/>
+            <a:off x="566928" y="4023360"/>
+            <a:ext cx="11055096" cy="502920"/>
+          </a:xfrm>
+          <a:prstGeom prst="roundRect">
+            <a:avLst>
+              <a:gd name="adj" fmla="val 12000"/>
+            </a:avLst>
+          </a:prstGeom>
+          <a:solidFill>
+            <a:srgbClr val="1B2A4A"/>
+          </a:solidFill>
+          <a:ln>
+            <a:noFill/>
+          </a:ln>
+          <a:effectLst/>
+        </p:spPr>
+        <p:style>
+          <a:lnRef idx="1">
+            <a:schemeClr val="accent1"/>
+          </a:lnRef>
+          <a:fillRef idx="3">
+            <a:schemeClr val="accent1"/>
+          </a:fillRef>
+          <a:effectRef idx="2">
+            <a:schemeClr val="accent1"/>
+          </a:effectRef>
+          <a:fontRef idx="minor">
+            <a:schemeClr val="lt1"/>
+          </a:fontRef>
+        </p:style>
+        <p:txBody>
+          <a:bodyPr rtlCol="0" anchor="ctr" wrap="square" lIns="73152" rIns="73152" tIns="36576" bIns="36576"/>
+          <a:lstStyle/>
+          <a:p>
+            <a:pPr algn="ctr"/>
+            <a:r>
+              <a:rPr sz="1500" b="1">
+                <a:solidFill>
+                  <a:srgbClr val="FFFFFF"/>
+                </a:solidFill>
+                <a:latin typeface="微软雅黑"/>
+                <a:ea typeface="微软雅黑"/>
+              </a:rPr>
+              <a:t>模式 B · DefenseCertificate（防守证明）</a:t>
+            </a:r>
+          </a:p>
+        </p:txBody>
+      </p:sp>
+      <p:sp>
+        <p:nvSpPr>
+          <p:cNvPr id="38" name="Rectangle 37"/>
+          <p:cNvSpPr/>
+          <p:nvPr/>
+        </p:nvSpPr>
+        <p:spPr>
+          <a:xfrm>
+            <a:off x="566928" y="4617720"/>
+            <a:ext cx="3593592" cy="566928"/>
+          </a:xfrm>
+          <a:prstGeom prst="rect">
+            <a:avLst/>
+          </a:prstGeom>
+          <a:solidFill>
+            <a:srgbClr val="2E7D4F"/>
+          </a:solidFill>
+          <a:ln>
+            <a:noFill/>
+          </a:ln>
+          <a:effectLst/>
+        </p:spPr>
+        <p:style>
+          <a:lnRef idx="1">
+            <a:schemeClr val="accent1"/>
+          </a:lnRef>
+          <a:fillRef idx="3">
+            <a:schemeClr val="accent1"/>
+          </a:fillRef>
+          <a:effectRef idx="2">
+            <a:schemeClr val="accent1"/>
+          </a:effectRef>
+          <a:fontRef idx="minor">
+            <a:schemeClr val="lt1"/>
+          </a:fontRef>
+        </p:style>
+        <p:txBody>
+          <a:bodyPr rtlCol="0" anchor="ctr"/>
+          <a:lstStyle/>
+          <a:p>
+            <a:pPr algn="ctr"/>
+          </a:p>
+        </p:txBody>
+      </p:sp>
+      <p:sp>
+        <p:nvSpPr>
+          <p:cNvPr id="39" name="TextBox 38"/>
+          <p:cNvSpPr txBox="1"/>
+          <p:nvPr/>
+        </p:nvSpPr>
+        <p:spPr>
+          <a:xfrm>
+            <a:off x="841247" y="4617720"/>
+            <a:ext cx="2103120" cy="566928"/>
+          </a:xfrm>
+          <a:prstGeom prst="rect">
+            <a:avLst/>
+          </a:prstGeom>
+          <a:noFill/>
+        </p:spPr>
+        <p:txBody>
+          <a:bodyPr wrap="square" anchor="ctr" lIns="0" rIns="0" tIns="0" bIns="0">
+            <a:spAutoFit/>
+          </a:bodyPr>
+          <a:lstStyle/>
+          <a:p>
+            <a:pPr algn="l"/>
+            <a:r>
+              <a:rPr sz="1700" b="1">
+                <a:solidFill>
+                  <a:srgbClr val="FFFFFF"/>
+                </a:solidFill>
+                <a:latin typeface="微软雅黑"/>
+                <a:ea typeface="微软雅黑"/>
+              </a:rPr>
+              <a:t>terminal</a:t>
+            </a:r>
+          </a:p>
+        </p:txBody>
+      </p:sp>
+      <p:sp>
+        <p:nvSpPr>
+          <p:cNvPr id="40" name="TextBox 39"/>
+          <p:cNvSpPr txBox="1"/>
+          <p:nvPr/>
+        </p:nvSpPr>
+        <p:spPr>
+          <a:xfrm>
+            <a:off x="2395728" y="4617720"/>
+            <a:ext cx="1737360" cy="566928"/>
+          </a:xfrm>
+          <a:prstGeom prst="rect">
+            <a:avLst/>
+          </a:prstGeom>
+          <a:noFill/>
+        </p:spPr>
+        <p:txBody>
+          <a:bodyPr wrap="square" anchor="ctr" lIns="0" rIns="0" tIns="0" bIns="0">
+            <a:spAutoFit/>
+          </a:bodyPr>
+          <a:lstStyle/>
+          <a:p>
+            <a:pPr algn="r"/>
+            <a:r>
+              <a:rPr sz="1300" b="0">
+                <a:solidFill>
+                  <a:srgbClr val="FFFFFF"/>
+                </a:solidFill>
+                <a:latin typeface="微软雅黑"/>
+                <a:ea typeface="微软雅黑"/>
+              </a:rPr>
+              <a:t>终局叶子</a:t>
+            </a:r>
+          </a:p>
+        </p:txBody>
+      </p:sp>
+      <p:sp>
+        <p:nvSpPr>
+          <p:cNvPr id="41" name="Rounded Rectangle 40"/>
+          <p:cNvSpPr/>
+          <p:nvPr/>
+        </p:nvSpPr>
+        <p:spPr>
+          <a:xfrm>
+            <a:off x="566928" y="5184648"/>
+            <a:ext cx="3593592" cy="1051560"/>
+          </a:xfrm>
+          <a:prstGeom prst="roundRect">
+            <a:avLst>
+              <a:gd name="adj" fmla="val 6000"/>
+            </a:avLst>
+          </a:prstGeom>
+          <a:solidFill>
+            <a:srgbClr val="F1F3F7"/>
+          </a:solidFill>
+          <a:ln>
+            <a:noFill/>
+          </a:ln>
+          <a:effectLst/>
+        </p:spPr>
+        <p:style>
+          <a:lnRef idx="1">
+            <a:schemeClr val="accent1"/>
+          </a:lnRef>
+          <a:fillRef idx="3">
+            <a:schemeClr val="accent1"/>
+          </a:fillRef>
+          <a:effectRef idx="2">
+            <a:schemeClr val="accent1"/>
+          </a:effectRef>
+          <a:fontRef idx="minor">
+            <a:schemeClr val="lt1"/>
+          </a:fontRef>
+        </p:style>
+        <p:txBody>
+          <a:bodyPr rtlCol="0" anchor="ctr"/>
+          <a:lstStyle/>
+          <a:p>
+            <a:pPr algn="ctr"/>
+          </a:p>
+        </p:txBody>
+      </p:sp>
+      <p:sp>
+        <p:nvSpPr>
+          <p:cNvPr id="42" name="Rectangle 41"/>
+          <p:cNvSpPr/>
+          <p:nvPr/>
+        </p:nvSpPr>
+        <p:spPr>
+          <a:xfrm>
+            <a:off x="886968" y="5376672"/>
+            <a:ext cx="137160" cy="137160"/>
+          </a:xfrm>
+          <a:prstGeom prst="rect">
+            <a:avLst/>
+          </a:prstGeom>
+          <a:solidFill>
+            <a:srgbClr val="E8A33D"/>
+          </a:solidFill>
+          <a:ln>
+            <a:noFill/>
+          </a:ln>
+          <a:effectLst/>
+        </p:spPr>
+        <p:style>
+          <a:lnRef idx="1">
+            <a:schemeClr val="accent1"/>
+          </a:lnRef>
+          <a:fillRef idx="3">
+            <a:schemeClr val="accent1"/>
+          </a:fillRef>
+          <a:effectRef idx="2">
+            <a:schemeClr val="accent1"/>
+          </a:effectRef>
+          <a:fontRef idx="minor">
+            <a:schemeClr val="lt1"/>
+          </a:fontRef>
+        </p:style>
+        <p:txBody>
+          <a:bodyPr rtlCol="0" anchor="ctr"/>
+          <a:lstStyle/>
+          <a:p>
+            <a:pPr algn="ctr"/>
+          </a:p>
+        </p:txBody>
+      </p:sp>
+      <p:sp>
+        <p:nvSpPr>
+          <p:cNvPr id="43" name="TextBox 42"/>
+          <p:cNvSpPr txBox="1"/>
+          <p:nvPr/>
+        </p:nvSpPr>
+        <p:spPr>
+          <a:xfrm>
+            <a:off x="1170432" y="5312664"/>
+            <a:ext cx="2788920" cy="365760"/>
+          </a:xfrm>
+          <a:prstGeom prst="rect">
+            <a:avLst/>
+          </a:prstGeom>
+          <a:noFill/>
+        </p:spPr>
+        <p:txBody>
+          <a:bodyPr wrap="square" anchor="t" lIns="0" rIns="0" tIns="0" bIns="0">
+            <a:spAutoFit/>
+          </a:bodyPr>
+          <a:lstStyle/>
+          <a:p>
+            <a:pPr algn="l"/>
+            <a:r>
+              <a:rPr sz="1350" b="0">
+                <a:solidFill>
+                  <a:srgbClr val="2B2B2B"/>
+                </a:solidFill>
+                <a:latin typeface="微软雅黑"/>
+                <a:ea typeface="微软雅黑"/>
+              </a:rPr>
+              <a:t>结果为防守方胜或和棋</a:t>
+            </a:r>
+          </a:p>
+        </p:txBody>
+      </p:sp>
+      <p:sp>
+        <p:nvSpPr>
+          <p:cNvPr id="44" name="Rectangle 43"/>
+          <p:cNvSpPr/>
+          <p:nvPr/>
+        </p:nvSpPr>
+        <p:spPr>
+          <a:xfrm>
+            <a:off x="886968" y="5760720"/>
+            <a:ext cx="137160" cy="137160"/>
+          </a:xfrm>
+          <a:prstGeom prst="rect">
+            <a:avLst/>
+          </a:prstGeom>
+          <a:solidFill>
+            <a:srgbClr val="E8A33D"/>
+          </a:solidFill>
+          <a:ln>
+            <a:noFill/>
+          </a:ln>
+          <a:effectLst/>
+        </p:spPr>
+        <p:style>
+          <a:lnRef idx="1">
+            <a:schemeClr val="accent1"/>
+          </a:lnRef>
+          <a:fillRef idx="3">
+            <a:schemeClr val="accent1"/>
+          </a:fillRef>
+          <a:effectRef idx="2">
+            <a:schemeClr val="accent1"/>
+          </a:effectRef>
+          <a:fontRef idx="minor">
+            <a:schemeClr val="lt1"/>
+          </a:fontRef>
+        </p:style>
+        <p:txBody>
+          <a:bodyPr rtlCol="0" anchor="ctr"/>
+          <a:lstStyle/>
+          <a:p>
+            <a:pPr algn="ctr"/>
+          </a:p>
+        </p:txBody>
+      </p:sp>
+      <p:sp>
+        <p:nvSpPr>
+          <p:cNvPr id="45" name="TextBox 44"/>
+          <p:cNvSpPr txBox="1"/>
+          <p:nvPr/>
+        </p:nvSpPr>
+        <p:spPr>
+          <a:xfrm>
+            <a:off x="1170432" y="5696712"/>
+            <a:ext cx="2788920" cy="365760"/>
+          </a:xfrm>
+          <a:prstGeom prst="rect">
+            <a:avLst/>
+          </a:prstGeom>
+          <a:noFill/>
+        </p:spPr>
+        <p:txBody>
+          <a:bodyPr wrap="square" anchor="t" lIns="0" rIns="0" tIns="0" bIns="0">
+            <a:spAutoFit/>
+          </a:bodyPr>
+          <a:lstStyle/>
+          <a:p>
+            <a:pPr algn="l"/>
+            <a:r>
+              <a:rPr sz="1350" b="0">
+                <a:solidFill>
+                  <a:srgbClr val="2B2B2B"/>
+                </a:solidFill>
+                <a:latin typeface="微软雅黑"/>
+                <a:ea typeface="微软雅黑"/>
+              </a:rPr>
+              <a:t>攻击方胜的叶子被拒绝</a:t>
+            </a:r>
+          </a:p>
+        </p:txBody>
+      </p:sp>
+      <p:sp>
+        <p:nvSpPr>
+          <p:cNvPr id="46" name="Rectangle 45"/>
+          <p:cNvSpPr/>
+          <p:nvPr/>
+        </p:nvSpPr>
+        <p:spPr>
+          <a:xfrm>
+            <a:off x="4343400" y="4617720"/>
+            <a:ext cx="3593592" cy="566928"/>
+          </a:xfrm>
+          <a:prstGeom prst="rect">
+            <a:avLst/>
+          </a:prstGeom>
+          <a:solidFill>
+            <a:srgbClr val="3B5998"/>
+          </a:solidFill>
+          <a:ln>
+            <a:noFill/>
+          </a:ln>
+          <a:effectLst/>
+        </p:spPr>
+        <p:style>
+          <a:lnRef idx="1">
+            <a:schemeClr val="accent1"/>
+          </a:lnRef>
+          <a:fillRef idx="3">
+            <a:schemeClr val="accent1"/>
+          </a:fillRef>
+          <a:effectRef idx="2">
+            <a:schemeClr val="accent1"/>
+          </a:effectRef>
+          <a:fontRef idx="minor">
+            <a:schemeClr val="lt1"/>
+          </a:fontRef>
+        </p:style>
+        <p:txBody>
+          <a:bodyPr rtlCol="0" anchor="ctr"/>
+          <a:lstStyle/>
+          <a:p>
+            <a:pPr algn="ctr"/>
+          </a:p>
+        </p:txBody>
+      </p:sp>
+      <p:sp>
+        <p:nvSpPr>
+          <p:cNvPr id="47" name="TextBox 46"/>
+          <p:cNvSpPr txBox="1"/>
+          <p:nvPr/>
+        </p:nvSpPr>
+        <p:spPr>
+          <a:xfrm>
+            <a:off x="4617720" y="4617720"/>
+            <a:ext cx="2103120" cy="566928"/>
+          </a:xfrm>
+          <a:prstGeom prst="rect">
+            <a:avLst/>
+          </a:prstGeom>
+          <a:noFill/>
+        </p:spPr>
+        <p:txBody>
+          <a:bodyPr wrap="square" anchor="ctr" lIns="0" rIns="0" tIns="0" bIns="0">
+            <a:spAutoFit/>
+          </a:bodyPr>
+          <a:lstStyle/>
+          <a:p>
+            <a:pPr algn="l"/>
+            <a:r>
+              <a:rPr sz="1700" b="1">
+                <a:solidFill>
+                  <a:srgbClr val="FFFFFF"/>
+                </a:solidFill>
+                <a:latin typeface="微软雅黑"/>
+                <a:ea typeface="微软雅黑"/>
+              </a:rPr>
+              <a:t>defenderMove</a:t>
+            </a:r>
+          </a:p>
+        </p:txBody>
+      </p:sp>
+      <p:sp>
+        <p:nvSpPr>
+          <p:cNvPr id="48" name="TextBox 47"/>
+          <p:cNvSpPr txBox="1"/>
+          <p:nvPr/>
+        </p:nvSpPr>
+        <p:spPr>
+          <a:xfrm>
+            <a:off x="6172200" y="4617720"/>
+            <a:ext cx="1737360" cy="566928"/>
+          </a:xfrm>
+          <a:prstGeom prst="rect">
+            <a:avLst/>
+          </a:prstGeom>
+          <a:noFill/>
+        </p:spPr>
+        <p:txBody>
+          <a:bodyPr wrap="square" anchor="ctr" lIns="0" rIns="0" tIns="0" bIns="0">
+            <a:spAutoFit/>
+          </a:bodyPr>
+          <a:lstStyle/>
+          <a:p>
+            <a:pPr algn="r"/>
+            <a:r>
+              <a:rPr sz="1300" b="0">
+                <a:solidFill>
+                  <a:srgbClr val="FFFFFF"/>
+                </a:solidFill>
+                <a:latin typeface="微软雅黑"/>
+                <a:ea typeface="微软雅黑"/>
+              </a:rPr>
+              <a:t>防守方回合</a:t>
+            </a:r>
+          </a:p>
+        </p:txBody>
+      </p:sp>
+      <p:sp>
+        <p:nvSpPr>
+          <p:cNvPr id="49" name="Rounded Rectangle 48"/>
+          <p:cNvSpPr/>
+          <p:nvPr/>
+        </p:nvSpPr>
+        <p:spPr>
+          <a:xfrm>
+            <a:off x="4343400" y="5184648"/>
+            <a:ext cx="3593592" cy="1051560"/>
+          </a:xfrm>
+          <a:prstGeom prst="roundRect">
+            <a:avLst>
+              <a:gd name="adj" fmla="val 6000"/>
+            </a:avLst>
+          </a:prstGeom>
+          <a:solidFill>
+            <a:srgbClr val="F1F3F7"/>
+          </a:solidFill>
+          <a:ln>
+            <a:noFill/>
+          </a:ln>
+          <a:effectLst/>
+        </p:spPr>
+        <p:style>
+          <a:lnRef idx="1">
+            <a:schemeClr val="accent1"/>
+          </a:lnRef>
+          <a:fillRef idx="3">
+            <a:schemeClr val="accent1"/>
+          </a:fillRef>
+          <a:effectRef idx="2">
+            <a:schemeClr val="accent1"/>
+          </a:effectRef>
+          <a:fontRef idx="minor">
+            <a:schemeClr val="lt1"/>
+          </a:fontRef>
+        </p:style>
+        <p:txBody>
+          <a:bodyPr rtlCol="0" anchor="ctr"/>
+          <a:lstStyle/>
+          <a:p>
+            <a:pPr algn="ctr"/>
+          </a:p>
+        </p:txBody>
+      </p:sp>
+      <p:sp>
+        <p:nvSpPr>
+          <p:cNvPr id="50" name="Rectangle 49"/>
+          <p:cNvSpPr/>
+          <p:nvPr/>
+        </p:nvSpPr>
+        <p:spPr>
+          <a:xfrm>
+            <a:off x="4663440" y="5376672"/>
+            <a:ext cx="137160" cy="137160"/>
+          </a:xfrm>
+          <a:prstGeom prst="rect">
+            <a:avLst/>
+          </a:prstGeom>
+          <a:solidFill>
+            <a:srgbClr val="E8A33D"/>
+          </a:solidFill>
+          <a:ln>
+            <a:noFill/>
+          </a:ln>
+          <a:effectLst/>
+        </p:spPr>
+        <p:style>
+          <a:lnRef idx="1">
+            <a:schemeClr val="accent1"/>
+          </a:lnRef>
+          <a:fillRef idx="3">
+            <a:schemeClr val="accent1"/>
+          </a:fillRef>
+          <a:effectRef idx="2">
+            <a:schemeClr val="accent1"/>
+          </a:effectRef>
+          <a:fontRef idx="minor">
+            <a:schemeClr val="lt1"/>
+          </a:fontRef>
+        </p:style>
+        <p:txBody>
+          <a:bodyPr rtlCol="0" anchor="ctr"/>
+          <a:lstStyle/>
+          <a:p>
+            <a:pPr algn="ctr"/>
+          </a:p>
+        </p:txBody>
+      </p:sp>
+      <p:sp>
+        <p:nvSpPr>
+          <p:cNvPr id="51" name="TextBox 50"/>
+          <p:cNvSpPr txBox="1"/>
+          <p:nvPr/>
+        </p:nvSpPr>
+        <p:spPr>
+          <a:xfrm>
+            <a:off x="4946904" y="5312664"/>
+            <a:ext cx="2788920" cy="365760"/>
+          </a:xfrm>
+          <a:prstGeom prst="rect">
+            <a:avLst/>
+          </a:prstGeom>
+          <a:noFill/>
+        </p:spPr>
+        <p:txBody>
+          <a:bodyPr wrap="square" anchor="t" lIns="0" rIns="0" tIns="0" bIns="0">
+            <a:spAutoFit/>
+          </a:bodyPr>
+          <a:lstStyle/>
+          <a:p>
+            <a:pPr algn="l"/>
+            <a:r>
+              <a:rPr sz="1350" b="0">
+                <a:solidFill>
+                  <a:srgbClr val="2B2B2B"/>
+                </a:solidFill>
+                <a:latin typeface="微软雅黑"/>
+                <a:ea typeface="微软雅黑"/>
+              </a:rPr>
+              <a:t>选一个保持防守的着法</a:t>
+            </a:r>
+          </a:p>
+        </p:txBody>
+      </p:sp>
+      <p:sp>
+        <p:nvSpPr>
+          <p:cNvPr id="52" name="Rectangle 51"/>
+          <p:cNvSpPr/>
+          <p:nvPr/>
+        </p:nvSpPr>
+        <p:spPr>
+          <a:xfrm>
+            <a:off x="4663440" y="5760720"/>
+            <a:ext cx="137160" cy="137160"/>
+          </a:xfrm>
+          <a:prstGeom prst="rect">
+            <a:avLst/>
+          </a:prstGeom>
+          <a:solidFill>
+            <a:srgbClr val="E8A33D"/>
+          </a:solidFill>
+          <a:ln>
+            <a:noFill/>
+          </a:ln>
+          <a:effectLst/>
+        </p:spPr>
+        <p:style>
+          <a:lnRef idx="1">
+            <a:schemeClr val="accent1"/>
+          </a:lnRef>
+          <a:fillRef idx="3">
+            <a:schemeClr val="accent1"/>
+          </a:fillRef>
+          <a:effectRef idx="2">
+            <a:schemeClr val="accent1"/>
+          </a:effectRef>
+          <a:fontRef idx="minor">
+            <a:schemeClr val="lt1"/>
+          </a:fontRef>
+        </p:style>
+        <p:txBody>
+          <a:bodyPr rtlCol="0" anchor="ctr"/>
+          <a:lstStyle/>
+          <a:p>
+            <a:pPr algn="ctr"/>
+          </a:p>
+        </p:txBody>
+      </p:sp>
+      <p:sp>
+        <p:nvSpPr>
+          <p:cNvPr id="53" name="TextBox 52"/>
+          <p:cNvSpPr txBox="1"/>
+          <p:nvPr/>
+        </p:nvSpPr>
+        <p:spPr>
+          <a:xfrm>
+            <a:off x="4946904" y="5696712"/>
+            <a:ext cx="2788920" cy="365760"/>
+          </a:xfrm>
+          <a:prstGeom prst="rect">
+            <a:avLst/>
+          </a:prstGeom>
+          <a:noFill/>
+        </p:spPr>
+        <p:txBody>
+          <a:bodyPr wrap="square" anchor="t" lIns="0" rIns="0" tIns="0" bIns="0">
+            <a:spAutoFit/>
+          </a:bodyPr>
+          <a:lstStyle/>
+          <a:p>
+            <a:pPr algn="l"/>
+            <a:r>
+              <a:rPr sz="1350" b="0">
+                <a:solidFill>
+                  <a:srgbClr val="2B2B2B"/>
+                </a:solidFill>
+                <a:latin typeface="微软雅黑"/>
+                <a:ea typeface="微软雅黑"/>
+              </a:rPr>
+              <a:t>指向一个子节点</a:t>
+            </a:r>
+          </a:p>
+        </p:txBody>
+      </p:sp>
+      <p:sp>
+        <p:nvSpPr>
+          <p:cNvPr id="54" name="Rectangle 53"/>
+          <p:cNvSpPr/>
+          <p:nvPr/>
+        </p:nvSpPr>
+        <p:spPr>
+          <a:xfrm>
+            <a:off x="8119871" y="4617720"/>
+            <a:ext cx="3593592" cy="566928"/>
+          </a:xfrm>
+          <a:prstGeom prst="rect">
+            <a:avLst/>
+          </a:prstGeom>
+          <a:solidFill>
+            <a:srgbClr val="D97B29"/>
+          </a:solidFill>
+          <a:ln>
+            <a:noFill/>
+          </a:ln>
+          <a:effectLst/>
+        </p:spPr>
+        <p:style>
+          <a:lnRef idx="1">
+            <a:schemeClr val="accent1"/>
+          </a:lnRef>
+          <a:fillRef idx="3">
+            <a:schemeClr val="accent1"/>
+          </a:fillRef>
+          <a:effectRef idx="2">
+            <a:schemeClr val="accent1"/>
+          </a:effectRef>
+          <a:fontRef idx="minor">
+            <a:schemeClr val="lt1"/>
+          </a:fontRef>
+        </p:style>
+        <p:txBody>
+          <a:bodyPr rtlCol="0" anchor="ctr"/>
+          <a:lstStyle/>
+          <a:p>
+            <a:pPr algn="ctr"/>
+          </a:p>
+        </p:txBody>
+      </p:sp>
+      <p:sp>
+        <p:nvSpPr>
+          <p:cNvPr id="55" name="TextBox 54"/>
+          <p:cNvSpPr txBox="1"/>
+          <p:nvPr/>
+        </p:nvSpPr>
+        <p:spPr>
+          <a:xfrm>
+            <a:off x="8394192" y="4617720"/>
+            <a:ext cx="2103120" cy="566928"/>
+          </a:xfrm>
+          <a:prstGeom prst="rect">
+            <a:avLst/>
+          </a:prstGeom>
+          <a:noFill/>
+        </p:spPr>
+        <p:txBody>
+          <a:bodyPr wrap="square" anchor="ctr" lIns="0" rIns="0" tIns="0" bIns="0">
+            <a:spAutoFit/>
+          </a:bodyPr>
+          <a:lstStyle/>
+          <a:p>
+            <a:pPr algn="l"/>
+            <a:r>
+              <a:rPr sz="1700" b="1">
+                <a:solidFill>
+                  <a:srgbClr val="FFFFFF"/>
+                </a:solidFill>
+                <a:latin typeface="微软雅黑"/>
+                <a:ea typeface="微软雅黑"/>
+              </a:rPr>
+              <a:t>attackerMoves</a:t>
+            </a:r>
+          </a:p>
+        </p:txBody>
+      </p:sp>
+      <p:sp>
+        <p:nvSpPr>
+          <p:cNvPr id="56" name="TextBox 55"/>
+          <p:cNvSpPr txBox="1"/>
+          <p:nvPr/>
+        </p:nvSpPr>
+        <p:spPr>
+          <a:xfrm>
+            <a:off x="9948672" y="4617720"/>
+            <a:ext cx="1737360" cy="566928"/>
+          </a:xfrm>
+          <a:prstGeom prst="rect">
+            <a:avLst/>
+          </a:prstGeom>
+          <a:noFill/>
+        </p:spPr>
+        <p:txBody>
+          <a:bodyPr wrap="square" anchor="ctr" lIns="0" rIns="0" tIns="0" bIns="0">
+            <a:spAutoFit/>
+          </a:bodyPr>
+          <a:lstStyle/>
+          <a:p>
+            <a:pPr algn="r"/>
+            <a:r>
+              <a:rPr sz="1300" b="0">
+                <a:solidFill>
+                  <a:srgbClr val="FFFFFF"/>
+                </a:solidFill>
+                <a:latin typeface="微软雅黑"/>
+                <a:ea typeface="微软雅黑"/>
+              </a:rPr>
+              <a:t>攻击方回合</a:t>
+            </a:r>
+          </a:p>
+        </p:txBody>
+      </p:sp>
+      <p:sp>
+        <p:nvSpPr>
+          <p:cNvPr id="57" name="Rounded Rectangle 56"/>
+          <p:cNvSpPr/>
+          <p:nvPr/>
+        </p:nvSpPr>
+        <p:spPr>
+          <a:xfrm>
+            <a:off x="8119871" y="5184648"/>
+            <a:ext cx="3593592" cy="1051560"/>
+          </a:xfrm>
+          <a:prstGeom prst="roundRect">
+            <a:avLst>
+              <a:gd name="adj" fmla="val 6000"/>
+            </a:avLst>
+          </a:prstGeom>
+          <a:solidFill>
+            <a:srgbClr val="F1F3F7"/>
+          </a:solidFill>
+          <a:ln>
+            <a:noFill/>
+          </a:ln>
+          <a:effectLst/>
+        </p:spPr>
+        <p:style>
+          <a:lnRef idx="1">
+            <a:schemeClr val="accent1"/>
+          </a:lnRef>
+          <a:fillRef idx="3">
+            <a:schemeClr val="accent1"/>
+          </a:fillRef>
+          <a:effectRef idx="2">
+            <a:schemeClr val="accent1"/>
+          </a:effectRef>
+          <a:fontRef idx="minor">
+            <a:schemeClr val="lt1"/>
+          </a:fontRef>
+        </p:style>
+        <p:txBody>
+          <a:bodyPr rtlCol="0" anchor="ctr"/>
+          <a:lstStyle/>
+          <a:p>
+            <a:pPr algn="ctr"/>
+          </a:p>
+        </p:txBody>
+      </p:sp>
+      <p:sp>
+        <p:nvSpPr>
+          <p:cNvPr id="58" name="Rectangle 57"/>
+          <p:cNvSpPr/>
+          <p:nvPr/>
+        </p:nvSpPr>
+        <p:spPr>
+          <a:xfrm>
+            <a:off x="8439911" y="5376672"/>
+            <a:ext cx="137160" cy="137160"/>
+          </a:xfrm>
+          <a:prstGeom prst="rect">
+            <a:avLst/>
+          </a:prstGeom>
+          <a:solidFill>
+            <a:srgbClr val="E8A33D"/>
+          </a:solidFill>
+          <a:ln>
+            <a:noFill/>
+          </a:ln>
+          <a:effectLst/>
+        </p:spPr>
+        <p:style>
+          <a:lnRef idx="1">
+            <a:schemeClr val="accent1"/>
+          </a:lnRef>
+          <a:fillRef idx="3">
+            <a:schemeClr val="accent1"/>
+          </a:fillRef>
+          <a:effectRef idx="2">
+            <a:schemeClr val="accent1"/>
+          </a:effectRef>
+          <a:fontRef idx="minor">
+            <a:schemeClr val="lt1"/>
+          </a:fontRef>
+        </p:style>
+        <p:txBody>
+          <a:bodyPr rtlCol="0" anchor="ctr"/>
+          <a:lstStyle/>
+          <a:p>
+            <a:pPr algn="ctr"/>
+          </a:p>
+        </p:txBody>
+      </p:sp>
+      <p:sp>
+        <p:nvSpPr>
+          <p:cNvPr id="59" name="TextBox 58"/>
+          <p:cNvSpPr txBox="1"/>
+          <p:nvPr/>
+        </p:nvSpPr>
+        <p:spPr>
+          <a:xfrm>
+            <a:off x="8723376" y="5312664"/>
+            <a:ext cx="2788920" cy="365760"/>
+          </a:xfrm>
+          <a:prstGeom prst="rect">
+            <a:avLst/>
+          </a:prstGeom>
+          <a:noFill/>
+        </p:spPr>
+        <p:txBody>
+          <a:bodyPr wrap="square" anchor="t" lIns="0" rIns="0" tIns="0" bIns="0">
+            <a:spAutoFit/>
+          </a:bodyPr>
+          <a:lstStyle/>
+          <a:p>
+            <a:pPr algn="l"/>
+            <a:r>
+              <a:rPr sz="1350" b="0">
+                <a:solidFill>
+                  <a:srgbClr val="2B2B2B"/>
+                </a:solidFill>
+                <a:latin typeface="微软雅黑"/>
+                <a:ea typeface="微软雅黑"/>
+              </a:rPr>
+              <a:t>覆盖全部合法应手</a:t>
+            </a:r>
+          </a:p>
+        </p:txBody>
+      </p:sp>
+      <p:sp>
+        <p:nvSpPr>
+          <p:cNvPr id="60" name="Rectangle 59"/>
+          <p:cNvSpPr/>
+          <p:nvPr/>
+        </p:nvSpPr>
+        <p:spPr>
+          <a:xfrm>
+            <a:off x="8439911" y="5760720"/>
+            <a:ext cx="137160" cy="137160"/>
+          </a:xfrm>
+          <a:prstGeom prst="rect">
+            <a:avLst/>
+          </a:prstGeom>
+          <a:solidFill>
+            <a:srgbClr val="E8A33D"/>
+          </a:solidFill>
+          <a:ln>
+            <a:noFill/>
+          </a:ln>
+          <a:effectLst/>
+        </p:spPr>
+        <p:style>
+          <a:lnRef idx="1">
+            <a:schemeClr val="accent1"/>
+          </a:lnRef>
+          <a:fillRef idx="3">
+            <a:schemeClr val="accent1"/>
+          </a:fillRef>
+          <a:effectRef idx="2">
+            <a:schemeClr val="accent1"/>
+          </a:effectRef>
+          <a:fontRef idx="minor">
+            <a:schemeClr val="lt1"/>
+          </a:fontRef>
+        </p:style>
+        <p:txBody>
+          <a:bodyPr rtlCol="0" anchor="ctr"/>
+          <a:lstStyle/>
+          <a:p>
+            <a:pPr algn="ctr"/>
+          </a:p>
+        </p:txBody>
+      </p:sp>
+      <p:sp>
+        <p:nvSpPr>
+          <p:cNvPr id="61" name="TextBox 60"/>
+          <p:cNvSpPr txBox="1"/>
+          <p:nvPr/>
+        </p:nvSpPr>
+        <p:spPr>
+          <a:xfrm>
+            <a:off x="8723376" y="5696712"/>
+            <a:ext cx="2788920" cy="365760"/>
+          </a:xfrm>
+          <a:prstGeom prst="rect">
+            <a:avLst/>
+          </a:prstGeom>
+          <a:noFill/>
+        </p:spPr>
+        <p:txBody>
+          <a:bodyPr wrap="square" anchor="t" lIns="0" rIns="0" tIns="0" bIns="0">
+            <a:spAutoFit/>
+          </a:bodyPr>
+          <a:lstStyle/>
+          <a:p>
+            <a:pPr algn="l"/>
+            <a:r>
+              <a:rPr sz="1350" b="0">
+                <a:solidFill>
+                  <a:srgbClr val="2B2B2B"/>
+                </a:solidFill>
+                <a:latin typeface="微软雅黑"/>
+                <a:ea typeface="微软雅黑"/>
+              </a:rPr>
+              <a:t>漏一个 → 整张被拒</a:t>
+            </a:r>
+          </a:p>
+        </p:txBody>
+      </p:sp>
+      <p:sp>
+        <p:nvSpPr>
+          <p:cNvPr id="62" name="Rounded Rectangle 61"/>
+          <p:cNvSpPr/>
+          <p:nvPr/>
+        </p:nvSpPr>
+        <p:spPr>
+          <a:xfrm>
+            <a:off x="566928" y="6355080"/>
+            <a:ext cx="11055096" cy="384048"/>
           </a:xfrm>
           <a:prstGeom prst="roundRect">
             <a:avLst>
@@ -9307,21 +10349,21 @@
           <a:p>
             <a:pPr algn="ctr"/>
             <a:r>
-              <a:rPr sz="1550" b="1">
+              <a:rPr sz="1300" b="1">
                 <a:solidFill>
                   <a:srgbClr val="C98A2D"/>
                 </a:solidFill>
                 <a:latin typeface="微软雅黑"/>
                 <a:ea typeface="微软雅黑"/>
               </a:rPr>
-              <a:t>编号规则：数组下标即编号，parent &lt; child，推荐先序布局；允许共享子树。</a:t>
-            </a:r>
-          </a:p>
-        </p:txBody>
-      </p:sp>
-      <p:sp>
-        <p:nvSpPr>
-          <p:cNvPr id="37" name="TextBox 36"/>
+              <a:t>编号规则：数组下标即编号，parent &lt; child；两种证书都推荐先序布局。</a:t>
+            </a:r>
+          </a:p>
+        </p:txBody>
+      </p:sp>
+      <p:sp>
+        <p:nvSpPr>
+          <p:cNvPr id="63" name="TextBox 62"/>
           <p:cNvSpPr txBox="1"/>
           <p:nvPr/>
         </p:nvSpPr>
@@ -9357,7 +10399,7 @@
       </p:sp>
       <p:sp>
         <p:nvSpPr>
-          <p:cNvPr id="38" name="TextBox 37"/>
+          <p:cNvPr id="64" name="TextBox 63"/>
           <p:cNvSpPr txBox="1"/>
           <p:nvPr/>
         </p:nvSpPr>
@@ -9734,7 +10776,7 @@
                 <a:latin typeface="微软雅黑"/>
                 <a:ea typeface="微软雅黑"/>
               </a:rPr>
-              <a:t>C++ 搜索器（DFPN / VCF）</a:t>
+              <a:t>C++ 搜索器（DFPN / VCF / DefenseSearcher）</a:t>
             </a:r>
           </a:p>
         </p:txBody>
@@ -10136,7 +11178,7 @@
                 <a:latin typeface="微软雅黑"/>
                 <a:ea typeface="微软雅黑"/>
               </a:rPr>
-              <a:t>checkCertificate</a:t>
+              <a:t>checkCertificate / checkDefenseCertificateAt</a:t>
             </a:r>
           </a:p>
         </p:txBody>
@@ -10376,7 +11418,7 @@
                 <a:latin typeface="微软雅黑"/>
                 <a:ea typeface="微软雅黑"/>
               </a:rPr>
-              <a:t>对手全应手覆盖</a:t>
+              <a:t>攻击方全应手覆盖</a:t>
             </a:r>
           </a:p>
         </p:txBody>
@@ -11675,7 +12717,7 @@
             </a:avLst>
           </a:prstGeom>
           <a:solidFill>
-            <a:srgbClr val="D97B29"/>
+            <a:srgbClr val="2E7D4F"/>
           </a:solidFill>
           <a:ln>
             <a:noFill/>
@@ -11709,7 +12751,7 @@
                 <a:latin typeface="微软雅黑"/>
                 <a:ea typeface="微软雅黑"/>
               </a:rPr>
-              <a:t>③ 有限深度</a:t>
+              <a:t>③ 防御证书链</a:t>
             </a:r>
           </a:p>
         </p:txBody>
@@ -11777,7 +12819,7 @@
             </a:avLst>
           </a:prstGeom>
           <a:solidFill>
-            <a:srgbClr val="FBEFDA"/>
+            <a:srgbClr val="E4F1E9"/>
           </a:solidFill>
           <a:ln>
             <a:noFill/>
@@ -11820,6 +12862,639 @@
           <a:prstGeom prst="roundRect">
             <a:avLst>
               <a:gd name="adj" fmla="val 25000"/>
+            </a:avLst>
+          </a:prstGeom>
+          <a:solidFill>
+            <a:srgbClr val="E4F1E9"/>
+          </a:solidFill>
+          <a:ln>
+            <a:noFill/>
+          </a:ln>
+          <a:effectLst/>
+        </p:spPr>
+        <p:style>
+          <a:lnRef idx="1">
+            <a:schemeClr val="accent1"/>
+          </a:lnRef>
+          <a:fillRef idx="3">
+            <a:schemeClr val="accent1"/>
+          </a:fillRef>
+          <a:effectRef idx="2">
+            <a:schemeClr val="accent1"/>
+          </a:effectRef>
+          <a:fontRef idx="minor">
+            <a:schemeClr val="lt1"/>
+          </a:fontRef>
+        </p:style>
+        <p:txBody>
+          <a:bodyPr rtlCol="0" anchor="ctr" wrap="square" lIns="73152" rIns="73152" tIns="36576" bIns="36576"/>
+          <a:lstStyle/>
+          <a:p>
+            <a:pPr algn="ctr"/>
+            <a:r>
+              <a:rPr sz="1300" b="1">
+                <a:solidFill>
+                  <a:srgbClr val="2E7D4F"/>
+                </a:solidFill>
+                <a:latin typeface="微软雅黑"/>
+                <a:ea typeface="微软雅黑"/>
+              </a:rPr>
+              <a:t>✓ 已完成</a:t>
+            </a:r>
+          </a:p>
+        </p:txBody>
+      </p:sp>
+      <p:sp>
+        <p:nvSpPr>
+          <p:cNvPr id="28" name="Rectangle 27"/>
+          <p:cNvSpPr/>
+          <p:nvPr/>
+        </p:nvSpPr>
+        <p:spPr>
+          <a:xfrm>
+            <a:off x="6611112" y="3108960"/>
+            <a:ext cx="137160" cy="137160"/>
+          </a:xfrm>
+          <a:prstGeom prst="rect">
+            <a:avLst/>
+          </a:prstGeom>
+          <a:solidFill>
+            <a:srgbClr val="E8A33D"/>
+          </a:solidFill>
+          <a:ln>
+            <a:noFill/>
+          </a:ln>
+          <a:effectLst/>
+        </p:spPr>
+        <p:style>
+          <a:lnRef idx="1">
+            <a:schemeClr val="accent1"/>
+          </a:lnRef>
+          <a:fillRef idx="3">
+            <a:schemeClr val="accent1"/>
+          </a:fillRef>
+          <a:effectRef idx="2">
+            <a:schemeClr val="accent1"/>
+          </a:effectRef>
+          <a:fontRef idx="minor">
+            <a:schemeClr val="lt1"/>
+          </a:fontRef>
+        </p:style>
+        <p:txBody>
+          <a:bodyPr rtlCol="0" anchor="ctr"/>
+          <a:lstStyle/>
+          <a:p>
+            <a:pPr algn="ctr"/>
+          </a:p>
+        </p:txBody>
+      </p:sp>
+      <p:sp>
+        <p:nvSpPr>
+          <p:cNvPr id="29" name="TextBox 28"/>
+          <p:cNvSpPr txBox="1"/>
+          <p:nvPr/>
+        </p:nvSpPr>
+        <p:spPr>
+          <a:xfrm>
+            <a:off x="6885432" y="3035808"/>
+            <a:ext cx="1874519" cy="731520"/>
+          </a:xfrm>
+          <a:prstGeom prst="rect">
+            <a:avLst/>
+          </a:prstGeom>
+          <a:noFill/>
+        </p:spPr>
+        <p:txBody>
+          <a:bodyPr wrap="square" anchor="t" lIns="0" rIns="0" tIns="0" bIns="0">
+            <a:spAutoFit/>
+          </a:bodyPr>
+          <a:lstStyle/>
+          <a:p>
+            <a:pPr algn="l">
+              <a:lnSpc>
+                <a:spcPct val="115000"/>
+              </a:lnSpc>
+            </a:pPr>
+            <a:r>
+              <a:rPr sz="1450" b="0">
+                <a:solidFill>
+                  <a:srgbClr val="2B2B2B"/>
+                </a:solidFill>
+                <a:latin typeface="微软雅黑"/>
+                <a:ea typeface="微软雅黑"/>
+              </a:rPr>
+              <a:t>--prove 模式</a:t>
+            </a:r>
+          </a:p>
+        </p:txBody>
+      </p:sp>
+      <p:sp>
+        <p:nvSpPr>
+          <p:cNvPr id="30" name="Rectangle 29"/>
+          <p:cNvSpPr/>
+          <p:nvPr/>
+        </p:nvSpPr>
+        <p:spPr>
+          <a:xfrm>
+            <a:off x="6611112" y="3886200"/>
+            <a:ext cx="137160" cy="137160"/>
+          </a:xfrm>
+          <a:prstGeom prst="rect">
+            <a:avLst/>
+          </a:prstGeom>
+          <a:solidFill>
+            <a:srgbClr val="E8A33D"/>
+          </a:solidFill>
+          <a:ln>
+            <a:noFill/>
+          </a:ln>
+          <a:effectLst/>
+        </p:spPr>
+        <p:style>
+          <a:lnRef idx="1">
+            <a:schemeClr val="accent1"/>
+          </a:lnRef>
+          <a:fillRef idx="3">
+            <a:schemeClr val="accent1"/>
+          </a:fillRef>
+          <a:effectRef idx="2">
+            <a:schemeClr val="accent1"/>
+          </a:effectRef>
+          <a:fontRef idx="minor">
+            <a:schemeClr val="lt1"/>
+          </a:fontRef>
+        </p:style>
+        <p:txBody>
+          <a:bodyPr rtlCol="0" anchor="ctr"/>
+          <a:lstStyle/>
+          <a:p>
+            <a:pPr algn="ctr"/>
+          </a:p>
+        </p:txBody>
+      </p:sp>
+      <p:sp>
+        <p:nvSpPr>
+          <p:cNvPr id="31" name="TextBox 30"/>
+          <p:cNvSpPr txBox="1"/>
+          <p:nvPr/>
+        </p:nvSpPr>
+        <p:spPr>
+          <a:xfrm>
+            <a:off x="6885432" y="3813048"/>
+            <a:ext cx="1874519" cy="731520"/>
+          </a:xfrm>
+          <a:prstGeom prst="rect">
+            <a:avLst/>
+          </a:prstGeom>
+          <a:noFill/>
+        </p:spPr>
+        <p:txBody>
+          <a:bodyPr wrap="square" anchor="t" lIns="0" rIns="0" tIns="0" bIns="0">
+            <a:spAutoFit/>
+          </a:bodyPr>
+          <a:lstStyle/>
+          <a:p>
+            <a:pPr algn="l">
+              <a:lnSpc>
+                <a:spcPct val="115000"/>
+              </a:lnSpc>
+            </a:pPr>
+            <a:r>
+              <a:rPr sz="1450" b="0">
+                <a:solidFill>
+                  <a:srgbClr val="2B2B2B"/>
+                </a:solidFill>
+                <a:latin typeface="微软雅黑"/>
+                <a:ea typeface="微软雅黑"/>
+              </a:rPr>
+              <a:t>DefenseCertificate + 检查器</a:t>
+            </a:r>
+          </a:p>
+        </p:txBody>
+      </p:sp>
+      <p:cxnSp>
+        <p:nvCxnSpPr>
+          <p:cNvPr id="32" name="Connector 31"/>
+          <p:cNvCxnSpPr/>
+          <p:nvPr/>
+        </p:nvCxnSpPr>
+        <p:spPr>
+          <a:xfrm>
+            <a:off x="8869680" y="1883664"/>
+            <a:ext cx="420624" cy="0"/>
+          </a:xfrm>
+          <a:prstGeom prst="line">
+            <a:avLst/>
+          </a:prstGeom>
+          <a:ln w="27940">
+            <a:solidFill>
+              <a:srgbClr val="6B7480"/>
+            </a:solidFill>
+            <a:tailEnd type="triangle" w="med" len="med"/>
+          </a:ln>
+          <a:effectLst/>
+        </p:spPr>
+        <p:style>
+          <a:lnRef idx="2">
+            <a:schemeClr val="accent1"/>
+          </a:lnRef>
+          <a:fillRef idx="0">
+            <a:schemeClr val="accent1"/>
+          </a:fillRef>
+          <a:effectRef idx="1">
+            <a:schemeClr val="accent1"/>
+          </a:effectRef>
+          <a:fontRef idx="minor">
+            <a:schemeClr val="tx1"/>
+          </a:fontRef>
+        </p:style>
+      </p:cxnSp>
+      <p:sp>
+        <p:nvSpPr>
+          <p:cNvPr id="33" name="Rounded Rectangle 32"/>
+          <p:cNvSpPr/>
+          <p:nvPr/>
+        </p:nvSpPr>
+        <p:spPr>
+          <a:xfrm>
+            <a:off x="9290304" y="1554480"/>
+            <a:ext cx="2487168" cy="658368"/>
+          </a:xfrm>
+          <a:prstGeom prst="roundRect">
+            <a:avLst>
+              <a:gd name="adj" fmla="val 15000"/>
+            </a:avLst>
+          </a:prstGeom>
+          <a:solidFill>
+            <a:srgbClr val="2E7D4F"/>
+          </a:solidFill>
+          <a:ln>
+            <a:noFill/>
+          </a:ln>
+          <a:effectLst/>
+        </p:spPr>
+        <p:style>
+          <a:lnRef idx="1">
+            <a:schemeClr val="accent1"/>
+          </a:lnRef>
+          <a:fillRef idx="3">
+            <a:schemeClr val="accent1"/>
+          </a:fillRef>
+          <a:effectRef idx="2">
+            <a:schemeClr val="accent1"/>
+          </a:effectRef>
+          <a:fontRef idx="minor">
+            <a:schemeClr val="lt1"/>
+          </a:fontRef>
+        </p:style>
+        <p:txBody>
+          <a:bodyPr rtlCol="0" anchor="ctr" wrap="square" lIns="73152" rIns="73152" tIns="36576" bIns="36576"/>
+          <a:lstStyle/>
+          <a:p>
+            <a:pPr algn="ctr"/>
+            <a:r>
+              <a:rPr sz="1700" b="1">
+                <a:solidFill>
+                  <a:srgbClr val="FFFFFF"/>
+                </a:solidFill>
+                <a:latin typeface="微软雅黑"/>
+                <a:ea typeface="微软雅黑"/>
+              </a:rPr>
+              <a:t>④ 中盘和棋</a:t>
+            </a:r>
+          </a:p>
+        </p:txBody>
+      </p:sp>
+      <p:sp>
+        <p:nvSpPr>
+          <p:cNvPr id="34" name="Rounded Rectangle 33"/>
+          <p:cNvSpPr/>
+          <p:nvPr/>
+        </p:nvSpPr>
+        <p:spPr>
+          <a:xfrm>
+            <a:off x="9290304" y="2212848"/>
+            <a:ext cx="2487168" cy="2880360"/>
+          </a:xfrm>
+          <a:prstGeom prst="roundRect">
+            <a:avLst>
+              <a:gd name="adj" fmla="val 6000"/>
+            </a:avLst>
+          </a:prstGeom>
+          <a:solidFill>
+            <a:srgbClr val="F1F3F7"/>
+          </a:solidFill>
+          <a:ln>
+            <a:noFill/>
+          </a:ln>
+          <a:effectLst/>
+        </p:spPr>
+        <p:style>
+          <a:lnRef idx="1">
+            <a:schemeClr val="accent1"/>
+          </a:lnRef>
+          <a:fillRef idx="3">
+            <a:schemeClr val="accent1"/>
+          </a:fillRef>
+          <a:effectRef idx="2">
+            <a:schemeClr val="accent1"/>
+          </a:effectRef>
+          <a:fontRef idx="minor">
+            <a:schemeClr val="lt1"/>
+          </a:fontRef>
+        </p:style>
+        <p:txBody>
+          <a:bodyPr rtlCol="0" anchor="ctr"/>
+          <a:lstStyle/>
+          <a:p>
+            <a:pPr algn="ctr"/>
+          </a:p>
+        </p:txBody>
+      </p:sp>
+      <p:sp>
+        <p:nvSpPr>
+          <p:cNvPr id="35" name="Rounded Rectangle 34"/>
+          <p:cNvSpPr/>
+          <p:nvPr/>
+        </p:nvSpPr>
+        <p:spPr>
+          <a:xfrm>
+            <a:off x="9518904" y="2395728"/>
+            <a:ext cx="2029968" cy="457200"/>
+          </a:xfrm>
+          <a:prstGeom prst="roundRect">
+            <a:avLst>
+              <a:gd name="adj" fmla="val 25000"/>
+            </a:avLst>
+          </a:prstGeom>
+          <a:solidFill>
+            <a:srgbClr val="E4F1E9"/>
+          </a:solidFill>
+          <a:ln>
+            <a:noFill/>
+          </a:ln>
+          <a:effectLst/>
+        </p:spPr>
+        <p:style>
+          <a:lnRef idx="1">
+            <a:schemeClr val="accent1"/>
+          </a:lnRef>
+          <a:fillRef idx="3">
+            <a:schemeClr val="accent1"/>
+          </a:fillRef>
+          <a:effectRef idx="2">
+            <a:schemeClr val="accent1"/>
+          </a:effectRef>
+          <a:fontRef idx="minor">
+            <a:schemeClr val="lt1"/>
+          </a:fontRef>
+        </p:style>
+        <p:txBody>
+          <a:bodyPr rtlCol="0" anchor="ctr"/>
+          <a:lstStyle/>
+          <a:p>
+            <a:pPr algn="ctr"/>
+          </a:p>
+        </p:txBody>
+      </p:sp>
+      <p:sp>
+        <p:nvSpPr>
+          <p:cNvPr id="36" name="Rounded Rectangle 35"/>
+          <p:cNvSpPr/>
+          <p:nvPr/>
+        </p:nvSpPr>
+        <p:spPr>
+          <a:xfrm>
+            <a:off x="9518904" y="2395728"/>
+            <a:ext cx="2029968" cy="457200"/>
+          </a:xfrm>
+          <a:prstGeom prst="roundRect">
+            <a:avLst>
+              <a:gd name="adj" fmla="val 25000"/>
+            </a:avLst>
+          </a:prstGeom>
+          <a:solidFill>
+            <a:srgbClr val="E4F1E9"/>
+          </a:solidFill>
+          <a:ln>
+            <a:noFill/>
+          </a:ln>
+          <a:effectLst/>
+        </p:spPr>
+        <p:style>
+          <a:lnRef idx="1">
+            <a:schemeClr val="accent1"/>
+          </a:lnRef>
+          <a:fillRef idx="3">
+            <a:schemeClr val="accent1"/>
+          </a:fillRef>
+          <a:effectRef idx="2">
+            <a:schemeClr val="accent1"/>
+          </a:effectRef>
+          <a:fontRef idx="minor">
+            <a:schemeClr val="lt1"/>
+          </a:fontRef>
+        </p:style>
+        <p:txBody>
+          <a:bodyPr rtlCol="0" anchor="ctr" wrap="square" lIns="73152" rIns="73152" tIns="36576" bIns="36576"/>
+          <a:lstStyle/>
+          <a:p>
+            <a:pPr algn="ctr"/>
+            <a:r>
+              <a:rPr sz="1300" b="1">
+                <a:solidFill>
+                  <a:srgbClr val="2E7D4F"/>
+                </a:solidFill>
+                <a:latin typeface="微软雅黑"/>
+                <a:ea typeface="微软雅黑"/>
+              </a:rPr>
+              <a:t>✓ 已完成</a:t>
+            </a:r>
+          </a:p>
+        </p:txBody>
+      </p:sp>
+      <p:sp>
+        <p:nvSpPr>
+          <p:cNvPr id="37" name="Rectangle 36"/>
+          <p:cNvSpPr/>
+          <p:nvPr/>
+        </p:nvSpPr>
+        <p:spPr>
+          <a:xfrm>
+            <a:off x="9518904" y="3108960"/>
+            <a:ext cx="137160" cy="137160"/>
+          </a:xfrm>
+          <a:prstGeom prst="rect">
+            <a:avLst/>
+          </a:prstGeom>
+          <a:solidFill>
+            <a:srgbClr val="E8A33D"/>
+          </a:solidFill>
+          <a:ln>
+            <a:noFill/>
+          </a:ln>
+          <a:effectLst/>
+        </p:spPr>
+        <p:style>
+          <a:lnRef idx="1">
+            <a:schemeClr val="accent1"/>
+          </a:lnRef>
+          <a:fillRef idx="3">
+            <a:schemeClr val="accent1"/>
+          </a:fillRef>
+          <a:effectRef idx="2">
+            <a:schemeClr val="accent1"/>
+          </a:effectRef>
+          <a:fontRef idx="minor">
+            <a:schemeClr val="lt1"/>
+          </a:fontRef>
+        </p:style>
+        <p:txBody>
+          <a:bodyPr rtlCol="0" anchor="ctr"/>
+          <a:lstStyle/>
+          <a:p>
+            <a:pPr algn="ctr"/>
+          </a:p>
+        </p:txBody>
+      </p:sp>
+      <p:sp>
+        <p:nvSpPr>
+          <p:cNvPr id="38" name="TextBox 37"/>
+          <p:cNvSpPr txBox="1"/>
+          <p:nvPr/>
+        </p:nvSpPr>
+        <p:spPr>
+          <a:xfrm>
+            <a:off x="9793224" y="3035808"/>
+            <a:ext cx="1874519" cy="731520"/>
+          </a:xfrm>
+          <a:prstGeom prst="rect">
+            <a:avLst/>
+          </a:prstGeom>
+          <a:noFill/>
+        </p:spPr>
+        <p:txBody>
+          <a:bodyPr wrap="square" anchor="t" lIns="0" rIns="0" tIns="0" bIns="0">
+            <a:spAutoFit/>
+          </a:bodyPr>
+          <a:lstStyle/>
+          <a:p>
+            <a:pPr algn="l">
+              <a:lnSpc>
+                <a:spcPct val="115000"/>
+              </a:lnSpc>
+            </a:pPr>
+            <a:r>
+              <a:rPr sz="1450" b="0">
+                <a:solidFill>
+                  <a:srgbClr val="2B2B2B"/>
+                </a:solidFill>
+                <a:latin typeface="微软雅黑"/>
+                <a:ea typeface="微软雅黑"/>
+              </a:rPr>
+              <a:t>9 个局面</a:t>
+            </a:r>
+          </a:p>
+        </p:txBody>
+      </p:sp>
+      <p:sp>
+        <p:nvSpPr>
+          <p:cNvPr id="39" name="Rectangle 38"/>
+          <p:cNvSpPr/>
+          <p:nvPr/>
+        </p:nvSpPr>
+        <p:spPr>
+          <a:xfrm>
+            <a:off x="9518904" y="3886200"/>
+            <a:ext cx="137160" cy="137160"/>
+          </a:xfrm>
+          <a:prstGeom prst="rect">
+            <a:avLst/>
+          </a:prstGeom>
+          <a:solidFill>
+            <a:srgbClr val="E8A33D"/>
+          </a:solidFill>
+          <a:ln>
+            <a:noFill/>
+          </a:ln>
+          <a:effectLst/>
+        </p:spPr>
+        <p:style>
+          <a:lnRef idx="1">
+            <a:schemeClr val="accent1"/>
+          </a:lnRef>
+          <a:fillRef idx="3">
+            <a:schemeClr val="accent1"/>
+          </a:fillRef>
+          <a:effectRef idx="2">
+            <a:schemeClr val="accent1"/>
+          </a:effectRef>
+          <a:fontRef idx="minor">
+            <a:schemeClr val="lt1"/>
+          </a:fontRef>
+        </p:style>
+        <p:txBody>
+          <a:bodyPr rtlCol="0" anchor="ctr"/>
+          <a:lstStyle/>
+          <a:p>
+            <a:pPr algn="ctr"/>
+          </a:p>
+        </p:txBody>
+      </p:sp>
+      <p:sp>
+        <p:nvSpPr>
+          <p:cNvPr id="40" name="TextBox 39"/>
+          <p:cNvSpPr txBox="1"/>
+          <p:nvPr/>
+        </p:nvSpPr>
+        <p:spPr>
+          <a:xfrm>
+            <a:off x="9793224" y="3813048"/>
+            <a:ext cx="1874519" cy="731520"/>
+          </a:xfrm>
+          <a:prstGeom prst="rect">
+            <a:avLst/>
+          </a:prstGeom>
+          <a:noFill/>
+        </p:spPr>
+        <p:txBody>
+          <a:bodyPr wrap="square" anchor="t" lIns="0" rIns="0" tIns="0" bIns="0">
+            <a:spAutoFit/>
+          </a:bodyPr>
+          <a:lstStyle/>
+          <a:p>
+            <a:pPr algn="l">
+              <a:lnSpc>
+                <a:spcPct val="115000"/>
+              </a:lnSpc>
+            </a:pPr>
+            <a:r>
+              <a:rPr sz="1450" b="0">
+                <a:solidFill>
+                  <a:srgbClr val="2B2B2B"/>
+                </a:solidFill>
+                <a:latin typeface="微软雅黑"/>
+                <a:ea typeface="微软雅黑"/>
+              </a:rPr>
+              <a:t>StandardDraw 定理</a:t>
+            </a:r>
+          </a:p>
+        </p:txBody>
+      </p:sp>
+      <p:sp>
+        <p:nvSpPr>
+          <p:cNvPr id="41" name="Rounded Rectangle 40"/>
+          <p:cNvSpPr/>
+          <p:nvPr/>
+        </p:nvSpPr>
+        <p:spPr>
+          <a:xfrm>
+            <a:off x="566928" y="5394960"/>
+            <a:ext cx="11055096" cy="685800"/>
+          </a:xfrm>
+          <a:prstGeom prst="roundRect">
+            <a:avLst>
+              <a:gd name="adj" fmla="val 18000"/>
             </a:avLst>
           </a:prstGeom>
           <a:solidFill>
@@ -11850,647 +13525,14 @@
           <a:p>
             <a:pPr algn="ctr"/>
             <a:r>
-              <a:rPr sz="1300" b="1">
+              <a:rPr sz="1500" b="1">
                 <a:solidFill>
                   <a:srgbClr val="C98A2D"/>
                 </a:solidFill>
                 <a:latin typeface="微软雅黑"/>
                 <a:ea typeface="微软雅黑"/>
               </a:rPr>
-              <a:t>◐ 部分完成</a:t>
-            </a:r>
-          </a:p>
-        </p:txBody>
-      </p:sp>
-      <p:sp>
-        <p:nvSpPr>
-          <p:cNvPr id="28" name="Rectangle 27"/>
-          <p:cNvSpPr/>
-          <p:nvPr/>
-        </p:nvSpPr>
-        <p:spPr>
-          <a:xfrm>
-            <a:off x="6611112" y="3108960"/>
-            <a:ext cx="137160" cy="137160"/>
-          </a:xfrm>
-          <a:prstGeom prst="rect">
-            <a:avLst/>
-          </a:prstGeom>
-          <a:solidFill>
-            <a:srgbClr val="E8A33D"/>
-          </a:solidFill>
-          <a:ln>
-            <a:noFill/>
-          </a:ln>
-          <a:effectLst/>
-        </p:spPr>
-        <p:style>
-          <a:lnRef idx="1">
-            <a:schemeClr val="accent1"/>
-          </a:lnRef>
-          <a:fillRef idx="3">
-            <a:schemeClr val="accent1"/>
-          </a:fillRef>
-          <a:effectRef idx="2">
-            <a:schemeClr val="accent1"/>
-          </a:effectRef>
-          <a:fontRef idx="minor">
-            <a:schemeClr val="lt1"/>
-          </a:fontRef>
-        </p:style>
-        <p:txBody>
-          <a:bodyPr rtlCol="0" anchor="ctr"/>
-          <a:lstStyle/>
-          <a:p>
-            <a:pPr algn="ctr"/>
-          </a:p>
-        </p:txBody>
-      </p:sp>
-      <p:sp>
-        <p:nvSpPr>
-          <p:cNvPr id="29" name="TextBox 28"/>
-          <p:cNvSpPr txBox="1"/>
-          <p:nvPr/>
-        </p:nvSpPr>
-        <p:spPr>
-          <a:xfrm>
-            <a:off x="6885432" y="3035808"/>
-            <a:ext cx="1874519" cy="731520"/>
-          </a:xfrm>
-          <a:prstGeom prst="rect">
-            <a:avLst/>
-          </a:prstGeom>
-          <a:noFill/>
-        </p:spPr>
-        <p:txBody>
-          <a:bodyPr wrap="square" anchor="t" lIns="0" rIns="0" tIns="0" bIns="0">
-            <a:spAutoFit/>
-          </a:bodyPr>
-          <a:lstStyle/>
-          <a:p>
-            <a:pPr algn="l">
-              <a:lnSpc>
-                <a:spcPct val="115000"/>
-              </a:lnSpc>
-            </a:pPr>
-            <a:r>
-              <a:rPr sz="1450" b="0">
-                <a:solidFill>
-                  <a:srgbClr val="2B2B2B"/>
-                </a:solidFill>
-                <a:latin typeface="微软雅黑"/>
-                <a:ea typeface="微软雅黑"/>
-              </a:rPr>
-              <a:t>参考实现存在</a:t>
-            </a:r>
-          </a:p>
-        </p:txBody>
-      </p:sp>
-      <p:sp>
-        <p:nvSpPr>
-          <p:cNvPr id="30" name="Rectangle 29"/>
-          <p:cNvSpPr/>
-          <p:nvPr/>
-        </p:nvSpPr>
-        <p:spPr>
-          <a:xfrm>
-            <a:off x="6611112" y="3886200"/>
-            <a:ext cx="137160" cy="137160"/>
-          </a:xfrm>
-          <a:prstGeom prst="rect">
-            <a:avLst/>
-          </a:prstGeom>
-          <a:solidFill>
-            <a:srgbClr val="E8A33D"/>
-          </a:solidFill>
-          <a:ln>
-            <a:noFill/>
-          </a:ln>
-          <a:effectLst/>
-        </p:spPr>
-        <p:style>
-          <a:lnRef idx="1">
-            <a:schemeClr val="accent1"/>
-          </a:lnRef>
-          <a:fillRef idx="3">
-            <a:schemeClr val="accent1"/>
-          </a:fillRef>
-          <a:effectRef idx="2">
-            <a:schemeClr val="accent1"/>
-          </a:effectRef>
-          <a:fontRef idx="minor">
-            <a:schemeClr val="lt1"/>
-          </a:fontRef>
-        </p:style>
-        <p:txBody>
-          <a:bodyPr rtlCol="0" anchor="ctr"/>
-          <a:lstStyle/>
-          <a:p>
-            <a:pPr algn="ctr"/>
-          </a:p>
-        </p:txBody>
-      </p:sp>
-      <p:sp>
-        <p:nvSpPr>
-          <p:cNvPr id="31" name="TextBox 30"/>
-          <p:cNvSpPr txBox="1"/>
-          <p:nvPr/>
-        </p:nvSpPr>
-        <p:spPr>
-          <a:xfrm>
-            <a:off x="6885432" y="3813048"/>
-            <a:ext cx="1874519" cy="731520"/>
-          </a:xfrm>
-          <a:prstGeom prst="rect">
-            <a:avLst/>
-          </a:prstGeom>
-          <a:noFill/>
-        </p:spPr>
-        <p:txBody>
-          <a:bodyPr wrap="square" anchor="t" lIns="0" rIns="0" tIns="0" bIns="0">
-            <a:spAutoFit/>
-          </a:bodyPr>
-          <a:lstStyle/>
-          <a:p>
-            <a:pPr algn="l">
-              <a:lnSpc>
-                <a:spcPct val="115000"/>
-              </a:lnSpc>
-            </a:pPr>
-            <a:r>
-              <a:rPr sz="1450" b="0">
-                <a:solidFill>
-                  <a:srgbClr val="2B2B2B"/>
-                </a:solidFill>
-                <a:latin typeface="微软雅黑"/>
-                <a:ea typeface="微软雅黑"/>
-              </a:rPr>
-              <a:t>规模仍然有限</a:t>
-            </a:r>
-          </a:p>
-        </p:txBody>
-      </p:sp>
-      <p:cxnSp>
-        <p:nvCxnSpPr>
-          <p:cNvPr id="32" name="Connector 31"/>
-          <p:cNvCxnSpPr/>
-          <p:nvPr/>
-        </p:nvCxnSpPr>
-        <p:spPr>
-          <a:xfrm>
-            <a:off x="8869680" y="1883664"/>
-            <a:ext cx="420624" cy="0"/>
-          </a:xfrm>
-          <a:prstGeom prst="line">
-            <a:avLst/>
-          </a:prstGeom>
-          <a:ln w="27940">
-            <a:solidFill>
-              <a:srgbClr val="6B7480"/>
-            </a:solidFill>
-            <a:tailEnd type="triangle" w="med" len="med"/>
-          </a:ln>
-          <a:effectLst/>
-        </p:spPr>
-        <p:style>
-          <a:lnRef idx="2">
-            <a:schemeClr val="accent1"/>
-          </a:lnRef>
-          <a:fillRef idx="0">
-            <a:schemeClr val="accent1"/>
-          </a:fillRef>
-          <a:effectRef idx="1">
-            <a:schemeClr val="accent1"/>
-          </a:effectRef>
-          <a:fontRef idx="minor">
-            <a:schemeClr val="tx1"/>
-          </a:fontRef>
-        </p:style>
-      </p:cxnSp>
-      <p:sp>
-        <p:nvSpPr>
-          <p:cNvPr id="33" name="Rounded Rectangle 32"/>
-          <p:cNvSpPr/>
-          <p:nvPr/>
-        </p:nvSpPr>
-        <p:spPr>
-          <a:xfrm>
-            <a:off x="9290304" y="1554480"/>
-            <a:ext cx="2487168" cy="658368"/>
-          </a:xfrm>
-          <a:prstGeom prst="roundRect">
-            <a:avLst>
-              <a:gd name="adj" fmla="val 15000"/>
-            </a:avLst>
-          </a:prstGeom>
-          <a:solidFill>
-            <a:srgbClr val="2E7D4F"/>
-          </a:solidFill>
-          <a:ln>
-            <a:noFill/>
-          </a:ln>
-          <a:effectLst/>
-        </p:spPr>
-        <p:style>
-          <a:lnRef idx="1">
-            <a:schemeClr val="accent1"/>
-          </a:lnRef>
-          <a:fillRef idx="3">
-            <a:schemeClr val="accent1"/>
-          </a:fillRef>
-          <a:effectRef idx="2">
-            <a:schemeClr val="accent1"/>
-          </a:effectRef>
-          <a:fontRef idx="minor">
-            <a:schemeClr val="lt1"/>
-          </a:fontRef>
-        </p:style>
-        <p:txBody>
-          <a:bodyPr rtlCol="0" anchor="ctr" wrap="square" lIns="73152" rIns="73152" tIns="36576" bIns="36576"/>
-          <a:lstStyle/>
-          <a:p>
-            <a:pPr algn="ctr"/>
-            <a:r>
-              <a:rPr sz="1700" b="1">
-                <a:solidFill>
-                  <a:srgbClr val="FFFFFF"/>
-                </a:solidFill>
-                <a:latin typeface="微软雅黑"/>
-                <a:ea typeface="微软雅黑"/>
-              </a:rPr>
-              <a:t>④ 导出复检</a:t>
-            </a:r>
-          </a:p>
-        </p:txBody>
-      </p:sp>
-      <p:sp>
-        <p:nvSpPr>
-          <p:cNvPr id="34" name="Rounded Rectangle 33"/>
-          <p:cNvSpPr/>
-          <p:nvPr/>
-        </p:nvSpPr>
-        <p:spPr>
-          <a:xfrm>
-            <a:off x="9290304" y="2212848"/>
-            <a:ext cx="2487168" cy="2880360"/>
-          </a:xfrm>
-          <a:prstGeom prst="roundRect">
-            <a:avLst>
-              <a:gd name="adj" fmla="val 6000"/>
-            </a:avLst>
-          </a:prstGeom>
-          <a:solidFill>
-            <a:srgbClr val="F1F3F7"/>
-          </a:solidFill>
-          <a:ln>
-            <a:noFill/>
-          </a:ln>
-          <a:effectLst/>
-        </p:spPr>
-        <p:style>
-          <a:lnRef idx="1">
-            <a:schemeClr val="accent1"/>
-          </a:lnRef>
-          <a:fillRef idx="3">
-            <a:schemeClr val="accent1"/>
-          </a:fillRef>
-          <a:effectRef idx="2">
-            <a:schemeClr val="accent1"/>
-          </a:effectRef>
-          <a:fontRef idx="minor">
-            <a:schemeClr val="lt1"/>
-          </a:fontRef>
-        </p:style>
-        <p:txBody>
-          <a:bodyPr rtlCol="0" anchor="ctr"/>
-          <a:lstStyle/>
-          <a:p>
-            <a:pPr algn="ctr"/>
-          </a:p>
-        </p:txBody>
-      </p:sp>
-      <p:sp>
-        <p:nvSpPr>
-          <p:cNvPr id="35" name="Rounded Rectangle 34"/>
-          <p:cNvSpPr/>
-          <p:nvPr/>
-        </p:nvSpPr>
-        <p:spPr>
-          <a:xfrm>
-            <a:off x="9518904" y="2395728"/>
-            <a:ext cx="2029968" cy="457200"/>
-          </a:xfrm>
-          <a:prstGeom prst="roundRect">
-            <a:avLst>
-              <a:gd name="adj" fmla="val 25000"/>
-            </a:avLst>
-          </a:prstGeom>
-          <a:solidFill>
-            <a:srgbClr val="E4F1E9"/>
-          </a:solidFill>
-          <a:ln>
-            <a:noFill/>
-          </a:ln>
-          <a:effectLst/>
-        </p:spPr>
-        <p:style>
-          <a:lnRef idx="1">
-            <a:schemeClr val="accent1"/>
-          </a:lnRef>
-          <a:fillRef idx="3">
-            <a:schemeClr val="accent1"/>
-          </a:fillRef>
-          <a:effectRef idx="2">
-            <a:schemeClr val="accent1"/>
-          </a:effectRef>
-          <a:fontRef idx="minor">
-            <a:schemeClr val="lt1"/>
-          </a:fontRef>
-        </p:style>
-        <p:txBody>
-          <a:bodyPr rtlCol="0" anchor="ctr"/>
-          <a:lstStyle/>
-          <a:p>
-            <a:pPr algn="ctr"/>
-          </a:p>
-        </p:txBody>
-      </p:sp>
-      <p:sp>
-        <p:nvSpPr>
-          <p:cNvPr id="36" name="Rounded Rectangle 35"/>
-          <p:cNvSpPr/>
-          <p:nvPr/>
-        </p:nvSpPr>
-        <p:spPr>
-          <a:xfrm>
-            <a:off x="9518904" y="2395728"/>
-            <a:ext cx="2029968" cy="457200"/>
-          </a:xfrm>
-          <a:prstGeom prst="roundRect">
-            <a:avLst>
-              <a:gd name="adj" fmla="val 25000"/>
-            </a:avLst>
-          </a:prstGeom>
-          <a:solidFill>
-            <a:srgbClr val="E4F1E9"/>
-          </a:solidFill>
-          <a:ln>
-            <a:noFill/>
-          </a:ln>
-          <a:effectLst/>
-        </p:spPr>
-        <p:style>
-          <a:lnRef idx="1">
-            <a:schemeClr val="accent1"/>
-          </a:lnRef>
-          <a:fillRef idx="3">
-            <a:schemeClr val="accent1"/>
-          </a:fillRef>
-          <a:effectRef idx="2">
-            <a:schemeClr val="accent1"/>
-          </a:effectRef>
-          <a:fontRef idx="minor">
-            <a:schemeClr val="lt1"/>
-          </a:fontRef>
-        </p:style>
-        <p:txBody>
-          <a:bodyPr rtlCol="0" anchor="ctr" wrap="square" lIns="73152" rIns="73152" tIns="36576" bIns="36576"/>
-          <a:lstStyle/>
-          <a:p>
-            <a:pPr algn="ctr"/>
-            <a:r>
-              <a:rPr sz="1300" b="1">
-                <a:solidFill>
-                  <a:srgbClr val="2E7D4F"/>
-                </a:solidFill>
-                <a:latin typeface="微软雅黑"/>
-                <a:ea typeface="微软雅黑"/>
-              </a:rPr>
-              <a:t>✓ 已完成</a:t>
-            </a:r>
-          </a:p>
-        </p:txBody>
-      </p:sp>
-      <p:sp>
-        <p:nvSpPr>
-          <p:cNvPr id="37" name="Rectangle 36"/>
-          <p:cNvSpPr/>
-          <p:nvPr/>
-        </p:nvSpPr>
-        <p:spPr>
-          <a:xfrm>
-            <a:off x="9518904" y="3108960"/>
-            <a:ext cx="137160" cy="137160"/>
-          </a:xfrm>
-          <a:prstGeom prst="rect">
-            <a:avLst/>
-          </a:prstGeom>
-          <a:solidFill>
-            <a:srgbClr val="E8A33D"/>
-          </a:solidFill>
-          <a:ln>
-            <a:noFill/>
-          </a:ln>
-          <a:effectLst/>
-        </p:spPr>
-        <p:style>
-          <a:lnRef idx="1">
-            <a:schemeClr val="accent1"/>
-          </a:lnRef>
-          <a:fillRef idx="3">
-            <a:schemeClr val="accent1"/>
-          </a:fillRef>
-          <a:effectRef idx="2">
-            <a:schemeClr val="accent1"/>
-          </a:effectRef>
-          <a:fontRef idx="minor">
-            <a:schemeClr val="lt1"/>
-          </a:fontRef>
-        </p:style>
-        <p:txBody>
-          <a:bodyPr rtlCol="0" anchor="ctr"/>
-          <a:lstStyle/>
-          <a:p>
-            <a:pPr algn="ctr"/>
-          </a:p>
-        </p:txBody>
-      </p:sp>
-      <p:sp>
-        <p:nvSpPr>
-          <p:cNvPr id="38" name="TextBox 37"/>
-          <p:cNvSpPr txBox="1"/>
-          <p:nvPr/>
-        </p:nvSpPr>
-        <p:spPr>
-          <a:xfrm>
-            <a:off x="9793224" y="3035808"/>
-            <a:ext cx="1874519" cy="731520"/>
-          </a:xfrm>
-          <a:prstGeom prst="rect">
-            <a:avLst/>
-          </a:prstGeom>
-          <a:noFill/>
-        </p:spPr>
-        <p:txBody>
-          <a:bodyPr wrap="square" anchor="t" lIns="0" rIns="0" tIns="0" bIns="0">
-            <a:spAutoFit/>
-          </a:bodyPr>
-          <a:lstStyle/>
-          <a:p>
-            <a:pPr algn="l">
-              <a:lnSpc>
-                <a:spcPct val="115000"/>
-              </a:lnSpc>
-            </a:pPr>
-            <a:r>
-              <a:rPr sz="1450" b="0">
-                <a:solidFill>
-                  <a:srgbClr val="2B2B2B"/>
-                </a:solidFill>
-                <a:latin typeface="微软雅黑"/>
-                <a:ea typeface="微软雅黑"/>
-              </a:rPr>
-              <a:t>C++ 导出 Lean 源码</a:t>
-            </a:r>
-          </a:p>
-        </p:txBody>
-      </p:sp>
-      <p:sp>
-        <p:nvSpPr>
-          <p:cNvPr id="39" name="Rectangle 38"/>
-          <p:cNvSpPr/>
-          <p:nvPr/>
-        </p:nvSpPr>
-        <p:spPr>
-          <a:xfrm>
-            <a:off x="9518904" y="3886200"/>
-            <a:ext cx="137160" cy="137160"/>
-          </a:xfrm>
-          <a:prstGeom prst="rect">
-            <a:avLst/>
-          </a:prstGeom>
-          <a:solidFill>
-            <a:srgbClr val="E8A33D"/>
-          </a:solidFill>
-          <a:ln>
-            <a:noFill/>
-          </a:ln>
-          <a:effectLst/>
-        </p:spPr>
-        <p:style>
-          <a:lnRef idx="1">
-            <a:schemeClr val="accent1"/>
-          </a:lnRef>
-          <a:fillRef idx="3">
-            <a:schemeClr val="accent1"/>
-          </a:fillRef>
-          <a:effectRef idx="2">
-            <a:schemeClr val="accent1"/>
-          </a:effectRef>
-          <a:fontRef idx="minor">
-            <a:schemeClr val="lt1"/>
-          </a:fontRef>
-        </p:style>
-        <p:txBody>
-          <a:bodyPr rtlCol="0" anchor="ctr"/>
-          <a:lstStyle/>
-          <a:p>
-            <a:pPr algn="ctr"/>
-          </a:p>
-        </p:txBody>
-      </p:sp>
-      <p:sp>
-        <p:nvSpPr>
-          <p:cNvPr id="40" name="TextBox 39"/>
-          <p:cNvSpPr txBox="1"/>
-          <p:nvPr/>
-        </p:nvSpPr>
-        <p:spPr>
-          <a:xfrm>
-            <a:off x="9793224" y="3813048"/>
-            <a:ext cx="1874519" cy="731520"/>
-          </a:xfrm>
-          <a:prstGeom prst="rect">
-            <a:avLst/>
-          </a:prstGeom>
-          <a:noFill/>
-        </p:spPr>
-        <p:txBody>
-          <a:bodyPr wrap="square" anchor="t" lIns="0" rIns="0" tIns="0" bIns="0">
-            <a:spAutoFit/>
-          </a:bodyPr>
-          <a:lstStyle/>
-          <a:p>
-            <a:pPr algn="l">
-              <a:lnSpc>
-                <a:spcPct val="115000"/>
-              </a:lnSpc>
-            </a:pPr>
-            <a:r>
-              <a:rPr sz="1450" b="0">
-                <a:solidFill>
-                  <a:srgbClr val="2B2B2B"/>
-                </a:solidFill>
-                <a:latin typeface="微软雅黑"/>
-                <a:ea typeface="微软雅黑"/>
-              </a:rPr>
-              <a:t>局部局面复检通过</a:t>
-            </a:r>
-          </a:p>
-        </p:txBody>
-      </p:sp>
-      <p:sp>
-        <p:nvSpPr>
-          <p:cNvPr id="41" name="Rounded Rectangle 40"/>
-          <p:cNvSpPr/>
-          <p:nvPr/>
-        </p:nvSpPr>
-        <p:spPr>
-          <a:xfrm>
-            <a:off x="566928" y="5394960"/>
-            <a:ext cx="11055096" cy="685800"/>
-          </a:xfrm>
-          <a:prstGeom prst="roundRect">
-            <a:avLst>
-              <a:gd name="adj" fmla="val 18000"/>
-            </a:avLst>
-          </a:prstGeom>
-          <a:solidFill>
-            <a:srgbClr val="FBEFDA"/>
-          </a:solidFill>
-          <a:ln>
-            <a:noFill/>
-          </a:ln>
-          <a:effectLst/>
-        </p:spPr>
-        <p:style>
-          <a:lnRef idx="1">
-            <a:schemeClr val="accent1"/>
-          </a:lnRef>
-          <a:fillRef idx="3">
-            <a:schemeClr val="accent1"/>
-          </a:fillRef>
-          <a:effectRef idx="2">
-            <a:schemeClr val="accent1"/>
-          </a:effectRef>
-          <a:fontRef idx="minor">
-            <a:schemeClr val="lt1"/>
-          </a:fontRef>
-        </p:style>
-        <p:txBody>
-          <a:bodyPr rtlCol="0" anchor="ctr" wrap="square" lIns="73152" rIns="73152" tIns="36576" bIns="36576"/>
-          <a:lstStyle/>
-          <a:p>
-            <a:pPr algn="ctr"/>
-            <a:r>
-              <a:rPr sz="1500" b="1">
-                <a:solidFill>
-                  <a:srgbClr val="C98A2D"/>
-                </a:solidFill>
-                <a:latin typeface="微软雅黑"/>
-                <a:ea typeface="微软雅黑"/>
-              </a:rPr>
-              <a:t>全部成果以 Lean 复检通过为准：一步胜 / 双应手 / 开四 VCF。</a:t>
+              <a:t>全部成果以 Lean 复检通过为准：一步胜 / 双应手 / 防御证书链 / 中盘和棋。</a:t>
             </a:r>
           </a:p>
         </p:txBody>
@@ -34243,7 +35285,7 @@
                 <a:latin typeface="微软雅黑"/>
                 <a:ea typeface="微软雅黑"/>
               </a:rPr>
-              <a:t>搜索器整体架构</a:t>
+              <a:t>搜索器整体架构：双模式</a:t>
             </a:r>
           </a:p>
         </p:txBody>
@@ -34292,8 +35334,77 @@
         </p:nvSpPr>
         <p:spPr>
           <a:xfrm>
-            <a:off x="566928" y="1691640"/>
-            <a:ext cx="1975104" cy="1188720"/>
+            <a:off x="566928" y="1234440"/>
+            <a:ext cx="11055096" cy="566928"/>
+          </a:xfrm>
+          <a:prstGeom prst="roundRect">
+            <a:avLst>
+              <a:gd name="adj" fmla="val 12000"/>
+            </a:avLst>
+          </a:prstGeom>
+          <a:solidFill>
+            <a:srgbClr val="1B2A4A"/>
+          </a:solidFill>
+          <a:ln>
+            <a:noFill/>
+          </a:ln>
+          <a:effectLst/>
+        </p:spPr>
+        <p:style>
+          <a:lnRef idx="1">
+            <a:schemeClr val="accent1"/>
+          </a:lnRef>
+          <a:fillRef idx="3">
+            <a:schemeClr val="accent1"/>
+          </a:fillRef>
+          <a:effectRef idx="2">
+            <a:schemeClr val="accent1"/>
+          </a:effectRef>
+          <a:fontRef idx="minor">
+            <a:schemeClr val="lt1"/>
+          </a:fontRef>
+        </p:style>
+        <p:txBody>
+          <a:bodyPr rtlCol="0" anchor="ctr" wrap="square" lIns="73152" rIns="73152" tIns="36576" bIns="36576"/>
+          <a:lstStyle/>
+          <a:p>
+            <a:pPr algn="ctr"/>
+            <a:r>
+              <a:rPr sz="1600" b="1">
+                <a:solidFill>
+                  <a:srgbClr val="FFFFFF"/>
+                </a:solidFill>
+                <a:latin typeface="微软雅黑"/>
+                <a:ea typeface="微软雅黑"/>
+              </a:rPr>
+              <a:t>模式 A · 强制胜搜索</a:t>
+            </a:r>
+          </a:p>
+          <a:p>
+            <a:pPr algn="ctr"/>
+            <a:r>
+              <a:rPr sz="1250" b="0">
+                <a:solidFill>
+                  <a:srgbClr val="CFD8E8"/>
+                </a:solidFill>
+                <a:latin typeface="微软雅黑"/>
+                <a:ea typeface="微软雅黑"/>
+              </a:rPr>
+              <a:t>目标：找到“某方能强制获胜”的策略树</a:t>
+            </a:r>
+          </a:p>
+        </p:txBody>
+      </p:sp>
+      <p:sp>
+        <p:nvSpPr>
+          <p:cNvPr id="7" name="Rounded Rectangle 6"/>
+          <p:cNvSpPr/>
+          <p:nvPr/>
+        </p:nvSpPr>
+        <p:spPr>
+          <a:xfrm>
+            <a:off x="566928" y="1965960"/>
+            <a:ext cx="1975104" cy="1005840"/>
           </a:xfrm>
           <a:prstGeom prst="roundRect">
             <a:avLst>
@@ -34328,7 +35439,7 @@
           <a:p>
             <a:pPr algn="ctr"/>
             <a:r>
-              <a:rPr sz="1600" b="1">
+              <a:rPr sz="1500" b="1">
                 <a:solidFill>
                   <a:srgbClr val="FFFFFF"/>
                 </a:solidFill>
@@ -34341,7 +35452,7 @@
           <a:p>
             <a:pPr algn="ctr"/>
             <a:r>
-              <a:rPr sz="1200" b="0">
+              <a:rPr sz="1150" b="0">
                 <a:solidFill>
                   <a:srgbClr val="FFFFFF"/>
                 </a:solidFill>
@@ -34355,19 +35466,19 @@
       </p:sp>
       <p:cxnSp>
         <p:nvCxnSpPr>
-          <p:cNvPr id="7" name="Connector 6"/>
+          <p:cNvPr id="8" name="Connector 7"/>
           <p:cNvCxnSpPr/>
           <p:nvPr/>
         </p:nvCxnSpPr>
         <p:spPr>
           <a:xfrm>
-            <a:off x="2542032" y="2286000"/>
+            <a:off x="2542032" y="2468880"/>
             <a:ext cx="384048" cy="0"/>
           </a:xfrm>
           <a:prstGeom prst="line">
             <a:avLst/>
           </a:prstGeom>
-          <a:ln w="27940">
+          <a:ln w="25400">
             <a:solidFill>
               <a:srgbClr val="6B7480"/>
             </a:solidFill>
@@ -34392,14 +35503,14 @@
       </p:cxnSp>
       <p:sp>
         <p:nvSpPr>
-          <p:cNvPr id="8" name="Rounded Rectangle 7"/>
+          <p:cNvPr id="9" name="Rounded Rectangle 8"/>
           <p:cNvSpPr/>
           <p:nvPr/>
         </p:nvSpPr>
         <p:spPr>
           <a:xfrm>
-            <a:off x="2926080" y="1691640"/>
-            <a:ext cx="1975104" cy="1188720"/>
+            <a:off x="2926080" y="1965960"/>
+            <a:ext cx="1975104" cy="1005840"/>
           </a:xfrm>
           <a:prstGeom prst="roundRect">
             <a:avLst>
@@ -34434,7 +35545,7 @@
           <a:p>
             <a:pPr algn="ctr"/>
             <a:r>
-              <a:rPr sz="1600" b="1">
+              <a:rPr sz="1500" b="1">
                 <a:solidFill>
                   <a:srgbClr val="FFFFFF"/>
                 </a:solidFill>
@@ -34447,7 +35558,7 @@
           <a:p>
             <a:pPr algn="ctr"/>
             <a:r>
-              <a:rPr sz="1200" b="0">
+              <a:rPr sz="1150" b="0">
                 <a:solidFill>
                   <a:srgbClr val="FFFFFF"/>
                 </a:solidFill>
@@ -34461,19 +35572,19 @@
       </p:sp>
       <p:cxnSp>
         <p:nvCxnSpPr>
-          <p:cNvPr id="9" name="Connector 8"/>
+          <p:cNvPr id="10" name="Connector 9"/>
           <p:cNvCxnSpPr/>
           <p:nvPr/>
         </p:nvCxnSpPr>
         <p:spPr>
           <a:xfrm>
-            <a:off x="4901184" y="2286000"/>
+            <a:off x="4901184" y="2468880"/>
             <a:ext cx="384048" cy="0"/>
           </a:xfrm>
           <a:prstGeom prst="line">
             <a:avLst/>
           </a:prstGeom>
-          <a:ln w="27940">
+          <a:ln w="25400">
             <a:solidFill>
               <a:srgbClr val="6B7480"/>
             </a:solidFill>
@@ -34498,14 +35609,14 @@
       </p:cxnSp>
       <p:sp>
         <p:nvSpPr>
-          <p:cNvPr id="10" name="Rounded Rectangle 9"/>
+          <p:cNvPr id="11" name="Rounded Rectangle 10"/>
           <p:cNvSpPr/>
           <p:nvPr/>
         </p:nvSpPr>
         <p:spPr>
           <a:xfrm>
-            <a:off x="5285232" y="1691640"/>
-            <a:ext cx="1975104" cy="1188720"/>
+            <a:off x="5285232" y="1965960"/>
+            <a:ext cx="1975104" cy="1005840"/>
           </a:xfrm>
           <a:prstGeom prst="roundRect">
             <a:avLst>
@@ -34540,7 +35651,7 @@
           <a:p>
             <a:pPr algn="ctr"/>
             <a:r>
-              <a:rPr sz="1600" b="1">
+              <a:rPr sz="1500" b="1">
                 <a:solidFill>
                   <a:srgbClr val="FFFFFF"/>
                 </a:solidFill>
@@ -34553,7 +35664,7 @@
           <a:p>
             <a:pPr algn="ctr"/>
             <a:r>
-              <a:rPr sz="1200" b="0">
+              <a:rPr sz="1150" b="0">
                 <a:solidFill>
                   <a:srgbClr val="FFFFFF"/>
                 </a:solidFill>
@@ -34567,19 +35678,19 @@
       </p:sp>
       <p:cxnSp>
         <p:nvCxnSpPr>
-          <p:cNvPr id="11" name="Connector 10"/>
+          <p:cNvPr id="12" name="Connector 11"/>
           <p:cNvCxnSpPr/>
           <p:nvPr/>
         </p:nvCxnSpPr>
         <p:spPr>
           <a:xfrm>
-            <a:off x="7260336" y="2286000"/>
+            <a:off x="7260336" y="2468880"/>
             <a:ext cx="384047" cy="0"/>
           </a:xfrm>
           <a:prstGeom prst="line">
             <a:avLst/>
           </a:prstGeom>
-          <a:ln w="27940">
+          <a:ln w="25400">
             <a:solidFill>
               <a:srgbClr val="6B7480"/>
             </a:solidFill>
@@ -34604,14 +35715,14 @@
       </p:cxnSp>
       <p:sp>
         <p:nvSpPr>
-          <p:cNvPr id="12" name="Rounded Rectangle 11"/>
+          <p:cNvPr id="13" name="Rounded Rectangle 12"/>
           <p:cNvSpPr/>
           <p:nvPr/>
         </p:nvSpPr>
         <p:spPr>
           <a:xfrm>
-            <a:off x="7644383" y="1691640"/>
-            <a:ext cx="1975104" cy="1188720"/>
+            <a:off x="7644383" y="1965960"/>
+            <a:ext cx="1975104" cy="1005840"/>
           </a:xfrm>
           <a:prstGeom prst="roundRect">
             <a:avLst>
@@ -34646,7 +35757,7 @@
           <a:p>
             <a:pPr algn="ctr"/>
             <a:r>
-              <a:rPr sz="1600" b="1">
+              <a:rPr sz="1500" b="1">
                 <a:solidFill>
                   <a:srgbClr val="FFFFFF"/>
                 </a:solidFill>
@@ -34659,7 +35770,7 @@
           <a:p>
             <a:pPr algn="ctr"/>
             <a:r>
-              <a:rPr sz="1200" b="0">
+              <a:rPr sz="1150" b="0">
                 <a:solidFill>
                   <a:srgbClr val="FFFFFF"/>
                 </a:solidFill>
@@ -34673,19 +35784,19 @@
       </p:sp>
       <p:cxnSp>
         <p:nvCxnSpPr>
-          <p:cNvPr id="13" name="Connector 12"/>
+          <p:cNvPr id="14" name="Connector 13"/>
           <p:cNvCxnSpPr/>
           <p:nvPr/>
         </p:nvCxnSpPr>
         <p:spPr>
           <a:xfrm>
-            <a:off x="9619488" y="2286000"/>
+            <a:off x="9619488" y="2468880"/>
             <a:ext cx="384048" cy="0"/>
           </a:xfrm>
           <a:prstGeom prst="line">
             <a:avLst/>
           </a:prstGeom>
-          <a:ln w="27940">
+          <a:ln w="25400">
             <a:solidFill>
               <a:srgbClr val="6B7480"/>
             </a:solidFill>
@@ -34710,14 +35821,14 @@
       </p:cxnSp>
       <p:sp>
         <p:nvSpPr>
-          <p:cNvPr id="14" name="Rounded Rectangle 13"/>
+          <p:cNvPr id="15" name="Rounded Rectangle 14"/>
           <p:cNvSpPr/>
           <p:nvPr/>
         </p:nvSpPr>
         <p:spPr>
           <a:xfrm>
-            <a:off x="10003536" y="1691640"/>
-            <a:ext cx="1975104" cy="1188720"/>
+            <a:off x="10003536" y="1965960"/>
+            <a:ext cx="1975104" cy="1005840"/>
           </a:xfrm>
           <a:prstGeom prst="roundRect">
             <a:avLst>
@@ -34752,6 +35863,75 @@
           <a:p>
             <a:pPr algn="ctr"/>
             <a:r>
+              <a:rPr sz="1500" b="1">
+                <a:solidFill>
+                  <a:srgbClr val="FFFFFF"/>
+                </a:solidFill>
+                <a:latin typeface="微软雅黑"/>
+                <a:ea typeface="微软雅黑"/>
+              </a:rPr>
+              <a:t>导出 Lean</a:t>
+            </a:r>
+          </a:p>
+          <a:p>
+            <a:pPr algn="ctr"/>
+            <a:r>
+              <a:rPr sz="1150" b="0">
+                <a:solidFill>
+                  <a:srgbClr val="FFFFFF"/>
+                </a:solidFill>
+                <a:latin typeface="微软雅黑"/>
+                <a:ea typeface="微软雅黑"/>
+              </a:rPr>
+              <a:t>def certificate</a:t>
+            </a:r>
+          </a:p>
+        </p:txBody>
+      </p:sp>
+      <p:sp>
+        <p:nvSpPr>
+          <p:cNvPr id="16" name="Rounded Rectangle 15"/>
+          <p:cNvSpPr/>
+          <p:nvPr/>
+        </p:nvSpPr>
+        <p:spPr>
+          <a:xfrm>
+            <a:off x="566928" y="3200400"/>
+            <a:ext cx="11055096" cy="566928"/>
+          </a:xfrm>
+          <a:prstGeom prst="roundRect">
+            <a:avLst>
+              <a:gd name="adj" fmla="val 12000"/>
+            </a:avLst>
+          </a:prstGeom>
+          <a:solidFill>
+            <a:srgbClr val="1B2A4A"/>
+          </a:solidFill>
+          <a:ln>
+            <a:noFill/>
+          </a:ln>
+          <a:effectLst/>
+        </p:spPr>
+        <p:style>
+          <a:lnRef idx="1">
+            <a:schemeClr val="accent1"/>
+          </a:lnRef>
+          <a:fillRef idx="3">
+            <a:schemeClr val="accent1"/>
+          </a:fillRef>
+          <a:effectRef idx="2">
+            <a:schemeClr val="accent1"/>
+          </a:effectRef>
+          <a:fontRef idx="minor">
+            <a:schemeClr val="lt1"/>
+          </a:fontRef>
+        </p:style>
+        <p:txBody>
+          <a:bodyPr rtlCol="0" anchor="ctr" wrap="square" lIns="73152" rIns="73152" tIns="36576" bIns="36576"/>
+          <a:lstStyle/>
+          <a:p>
+            <a:pPr algn="ctr"/>
+            <a:r>
               <a:rPr sz="1600" b="1">
                 <a:solidFill>
                   <a:srgbClr val="FFFFFF"/>
@@ -34759,19 +35939,512 @@
                 <a:latin typeface="微软雅黑"/>
                 <a:ea typeface="微软雅黑"/>
               </a:rPr>
-              <a:t>导出 Lean 源码</a:t>
-            </a:r>
-          </a:p>
-          <a:p>
-            <a:pPr algn="ctr"/>
-            <a:r>
-              <a:rPr sz="1200" b="0">
+              <a:t>模式 B · 防守证明</a:t>
+            </a:r>
+          </a:p>
+          <a:p>
+            <a:pPr algn="ctr"/>
+            <a:r>
+              <a:rPr sz="1250" b="0">
+                <a:solidFill>
+                  <a:srgbClr val="CFD8E8"/>
+                </a:solidFill>
+                <a:latin typeface="微软雅黑"/>
+                <a:ea typeface="微软雅黑"/>
+              </a:rPr>
+              <a:t>目标：证明“防守方能阻止对方获胜”（--prove prevent-black-win | prevent-white-win）</a:t>
+            </a:r>
+          </a:p>
+        </p:txBody>
+      </p:sp>
+      <p:sp>
+        <p:nvSpPr>
+          <p:cNvPr id="17" name="Rounded Rectangle 16"/>
+          <p:cNvSpPr/>
+          <p:nvPr/>
+        </p:nvSpPr>
+        <p:spPr>
+          <a:xfrm>
+            <a:off x="566928" y="3931920"/>
+            <a:ext cx="1975104" cy="1005840"/>
+          </a:xfrm>
+          <a:prstGeom prst="roundRect">
+            <a:avLst>
+              <a:gd name="adj" fmla="val 12000"/>
+            </a:avLst>
+          </a:prstGeom>
+          <a:solidFill>
+            <a:srgbClr val="2C3E63"/>
+          </a:solidFill>
+          <a:ln>
+            <a:noFill/>
+          </a:ln>
+          <a:effectLst/>
+        </p:spPr>
+        <p:style>
+          <a:lnRef idx="1">
+            <a:schemeClr val="accent1"/>
+          </a:lnRef>
+          <a:fillRef idx="3">
+            <a:schemeClr val="accent1"/>
+          </a:fillRef>
+          <a:effectRef idx="2">
+            <a:schemeClr val="accent1"/>
+          </a:effectRef>
+          <a:fontRef idx="minor">
+            <a:schemeClr val="lt1"/>
+          </a:fontRef>
+        </p:style>
+        <p:txBody>
+          <a:bodyPr rtlCol="0" anchor="ctr" wrap="square" lIns="73152" rIns="73152" tIns="36576" bIns="36576"/>
+          <a:lstStyle/>
+          <a:p>
+            <a:pPr algn="ctr"/>
+            <a:r>
+              <a:rPr sz="1500" b="1">
                 <a:solidFill>
                   <a:srgbClr val="FFFFFF"/>
                 </a:solidFill>
                 <a:latin typeface="微软雅黑"/>
                 <a:ea typeface="微软雅黑"/>
               </a:rPr>
+              <a:t>输入局面</a:t>
+            </a:r>
+          </a:p>
+          <a:p>
+            <a:pPr algn="ctr"/>
+            <a:r>
+              <a:rPr sz="1150" b="0">
+                <a:solidFill>
+                  <a:srgbClr val="FFFFFF"/>
+                </a:solidFill>
+                <a:latin typeface="微软雅黑"/>
+                <a:ea typeface="微软雅黑"/>
+              </a:rPr>
+              <a:t>--input / --root empty</a:t>
+            </a:r>
+          </a:p>
+        </p:txBody>
+      </p:sp>
+      <p:cxnSp>
+        <p:nvCxnSpPr>
+          <p:cNvPr id="18" name="Connector 17"/>
+          <p:cNvCxnSpPr/>
+          <p:nvPr/>
+        </p:nvCxnSpPr>
+        <p:spPr>
+          <a:xfrm>
+            <a:off x="2542032" y="4434840"/>
+            <a:ext cx="384048" cy="0"/>
+          </a:xfrm>
+          <a:prstGeom prst="line">
+            <a:avLst/>
+          </a:prstGeom>
+          <a:ln w="25400">
+            <a:solidFill>
+              <a:srgbClr val="6B7480"/>
+            </a:solidFill>
+            <a:tailEnd type="triangle" w="med" len="med"/>
+          </a:ln>
+          <a:effectLst/>
+        </p:spPr>
+        <p:style>
+          <a:lnRef idx="2">
+            <a:schemeClr val="accent1"/>
+          </a:lnRef>
+          <a:fillRef idx="0">
+            <a:schemeClr val="accent1"/>
+          </a:fillRef>
+          <a:effectRef idx="1">
+            <a:schemeClr val="accent1"/>
+          </a:effectRef>
+          <a:fontRef idx="minor">
+            <a:schemeClr val="tx1"/>
+          </a:fontRef>
+        </p:style>
+      </p:cxnSp>
+      <p:sp>
+        <p:nvSpPr>
+          <p:cNvPr id="19" name="Rounded Rectangle 18"/>
+          <p:cNvSpPr/>
+          <p:nvPr/>
+        </p:nvSpPr>
+        <p:spPr>
+          <a:xfrm>
+            <a:off x="2926080" y="3931920"/>
+            <a:ext cx="1975104" cy="1005840"/>
+          </a:xfrm>
+          <a:prstGeom prst="roundRect">
+            <a:avLst>
+              <a:gd name="adj" fmla="val 12000"/>
+            </a:avLst>
+          </a:prstGeom>
+          <a:solidFill>
+            <a:srgbClr val="3B5998"/>
+          </a:solidFill>
+          <a:ln>
+            <a:noFill/>
+          </a:ln>
+          <a:effectLst/>
+        </p:spPr>
+        <p:style>
+          <a:lnRef idx="1">
+            <a:schemeClr val="accent1"/>
+          </a:lnRef>
+          <a:fillRef idx="3">
+            <a:schemeClr val="accent1"/>
+          </a:fillRef>
+          <a:effectRef idx="2">
+            <a:schemeClr val="accent1"/>
+          </a:effectRef>
+          <a:fontRef idx="minor">
+            <a:schemeClr val="lt1"/>
+          </a:fontRef>
+        </p:style>
+        <p:txBody>
+          <a:bodyPr rtlCol="0" anchor="ctr" wrap="square" lIns="73152" rIns="73152" tIns="36576" bIns="36576"/>
+          <a:lstStyle/>
+          <a:p>
+            <a:pPr algn="ctr"/>
+            <a:r>
+              <a:rPr sz="1500" b="1">
+                <a:solidFill>
+                  <a:srgbClr val="FFFFFF"/>
+                </a:solidFill>
+                <a:latin typeface="微软雅黑"/>
+                <a:ea typeface="微软雅黑"/>
+              </a:rPr>
+              <a:t>DefenseSearcher</a:t>
+            </a:r>
+          </a:p>
+          <a:p>
+            <a:pPr algn="ctr"/>
+            <a:r>
+              <a:rPr sz="1150" b="0">
+                <a:solidFill>
+                  <a:srgbClr val="FFFFFF"/>
+                </a:solidFill>
+                <a:latin typeface="微软雅黑"/>
+                <a:ea typeface="微软雅黑"/>
+              </a:rPr>
+              <a:t>完整 AND/OR 搜索</a:t>
+            </a:r>
+          </a:p>
+        </p:txBody>
+      </p:sp>
+      <p:cxnSp>
+        <p:nvCxnSpPr>
+          <p:cNvPr id="20" name="Connector 19"/>
+          <p:cNvCxnSpPr/>
+          <p:nvPr/>
+        </p:nvCxnSpPr>
+        <p:spPr>
+          <a:xfrm>
+            <a:off x="4901184" y="4434840"/>
+            <a:ext cx="384048" cy="0"/>
+          </a:xfrm>
+          <a:prstGeom prst="line">
+            <a:avLst/>
+          </a:prstGeom>
+          <a:ln w="25400">
+            <a:solidFill>
+              <a:srgbClr val="6B7480"/>
+            </a:solidFill>
+            <a:tailEnd type="triangle" w="med" len="med"/>
+          </a:ln>
+          <a:effectLst/>
+        </p:spPr>
+        <p:style>
+          <a:lnRef idx="2">
+            <a:schemeClr val="accent1"/>
+          </a:lnRef>
+          <a:fillRef idx="0">
+            <a:schemeClr val="accent1"/>
+          </a:fillRef>
+          <a:effectRef idx="1">
+            <a:schemeClr val="accent1"/>
+          </a:effectRef>
+          <a:fontRef idx="minor">
+            <a:schemeClr val="tx1"/>
+          </a:fontRef>
+        </p:style>
+      </p:cxnSp>
+      <p:sp>
+        <p:nvSpPr>
+          <p:cNvPr id="21" name="Rounded Rectangle 20"/>
+          <p:cNvSpPr/>
+          <p:nvPr/>
+        </p:nvSpPr>
+        <p:spPr>
+          <a:xfrm>
+            <a:off x="5285232" y="3931920"/>
+            <a:ext cx="1975104" cy="1005840"/>
+          </a:xfrm>
+          <a:prstGeom prst="roundRect">
+            <a:avLst>
+              <a:gd name="adj" fmla="val 12000"/>
+            </a:avLst>
+          </a:prstGeom>
+          <a:solidFill>
+            <a:srgbClr val="C98A2D"/>
+          </a:solidFill>
+          <a:ln>
+            <a:noFill/>
+          </a:ln>
+          <a:effectLst/>
+        </p:spPr>
+        <p:style>
+          <a:lnRef idx="1">
+            <a:schemeClr val="accent1"/>
+          </a:lnRef>
+          <a:fillRef idx="3">
+            <a:schemeClr val="accent1"/>
+          </a:fillRef>
+          <a:effectRef idx="2">
+            <a:schemeClr val="accent1"/>
+          </a:effectRef>
+          <a:fontRef idx="minor">
+            <a:schemeClr val="lt1"/>
+          </a:fontRef>
+        </p:style>
+        <p:txBody>
+          <a:bodyPr rtlCol="0" anchor="ctr" wrap="square" lIns="73152" rIns="73152" tIns="36576" bIns="36576"/>
+          <a:lstStyle/>
+          <a:p>
+            <a:pPr algn="ctr"/>
+            <a:r>
+              <a:rPr sz="1500" b="1">
+                <a:solidFill>
+                  <a:srgbClr val="FFFFFF"/>
+                </a:solidFill>
+                <a:latin typeface="微软雅黑"/>
+                <a:ea typeface="微软雅黑"/>
+              </a:rPr>
+              <a:t>严格传播</a:t>
+            </a:r>
+          </a:p>
+          <a:p>
+            <a:pPr algn="ctr"/>
+            <a:r>
+              <a:rPr sz="1150" b="0">
+                <a:solidFill>
+                  <a:srgbClr val="FFFFFF"/>
+                </a:solidFill>
+                <a:latin typeface="微软雅黑"/>
+                <a:ea typeface="微软雅黑"/>
+              </a:rPr>
+              <a:t>found / refuted / unknown</a:t>
+            </a:r>
+          </a:p>
+        </p:txBody>
+      </p:sp>
+      <p:cxnSp>
+        <p:nvCxnSpPr>
+          <p:cNvPr id="22" name="Connector 21"/>
+          <p:cNvCxnSpPr/>
+          <p:nvPr/>
+        </p:nvCxnSpPr>
+        <p:spPr>
+          <a:xfrm>
+            <a:off x="7260336" y="4434840"/>
+            <a:ext cx="384047" cy="0"/>
+          </a:xfrm>
+          <a:prstGeom prst="line">
+            <a:avLst/>
+          </a:prstGeom>
+          <a:ln w="25400">
+            <a:solidFill>
+              <a:srgbClr val="6B7480"/>
+            </a:solidFill>
+            <a:tailEnd type="triangle" w="med" len="med"/>
+          </a:ln>
+          <a:effectLst/>
+        </p:spPr>
+        <p:style>
+          <a:lnRef idx="2">
+            <a:schemeClr val="accent1"/>
+          </a:lnRef>
+          <a:fillRef idx="0">
+            <a:schemeClr val="accent1"/>
+          </a:fillRef>
+          <a:effectRef idx="1">
+            <a:schemeClr val="accent1"/>
+          </a:effectRef>
+          <a:fontRef idx="minor">
+            <a:schemeClr val="tx1"/>
+          </a:fontRef>
+        </p:style>
+      </p:cxnSp>
+      <p:sp>
+        <p:nvSpPr>
+          <p:cNvPr id="23" name="Rounded Rectangle 22"/>
+          <p:cNvSpPr/>
+          <p:nvPr/>
+        </p:nvSpPr>
+        <p:spPr>
+          <a:xfrm>
+            <a:off x="7644383" y="3931920"/>
+            <a:ext cx="1975104" cy="1005840"/>
+          </a:xfrm>
+          <a:prstGeom prst="roundRect">
+            <a:avLst>
+              <a:gd name="adj" fmla="val 12000"/>
+            </a:avLst>
+          </a:prstGeom>
+          <a:solidFill>
+            <a:srgbClr val="D97B29"/>
+          </a:solidFill>
+          <a:ln>
+            <a:noFill/>
+          </a:ln>
+          <a:effectLst/>
+        </p:spPr>
+        <p:style>
+          <a:lnRef idx="1">
+            <a:schemeClr val="accent1"/>
+          </a:lnRef>
+          <a:fillRef idx="3">
+            <a:schemeClr val="accent1"/>
+          </a:fillRef>
+          <a:effectRef idx="2">
+            <a:schemeClr val="accent1"/>
+          </a:effectRef>
+          <a:fontRef idx="minor">
+            <a:schemeClr val="lt1"/>
+          </a:fontRef>
+        </p:style>
+        <p:txBody>
+          <a:bodyPr rtlCol="0" anchor="ctr" wrap="square" lIns="73152" rIns="73152" tIns="36576" bIns="36576"/>
+          <a:lstStyle/>
+          <a:p>
+            <a:pPr algn="ctr"/>
+            <a:r>
+              <a:rPr sz="1500" b="1">
+                <a:solidFill>
+                  <a:srgbClr val="FFFFFF"/>
+                </a:solidFill>
+                <a:latin typeface="微软雅黑"/>
+                <a:ea typeface="微软雅黑"/>
+              </a:rPr>
+              <a:t>候选证书</a:t>
+            </a:r>
+          </a:p>
+          <a:p>
+            <a:pPr algn="ctr"/>
+            <a:r>
+              <a:rPr sz="1150" b="0">
+                <a:solidFill>
+                  <a:srgbClr val="FFFFFF"/>
+                </a:solidFill>
+                <a:latin typeface="微软雅黑"/>
+                <a:ea typeface="微软雅黑"/>
+              </a:rPr>
+              <a:t>DefenseCertificate</a:t>
+            </a:r>
+          </a:p>
+        </p:txBody>
+      </p:sp>
+      <p:cxnSp>
+        <p:nvCxnSpPr>
+          <p:cNvPr id="24" name="Connector 23"/>
+          <p:cNvCxnSpPr/>
+          <p:nvPr/>
+        </p:nvCxnSpPr>
+        <p:spPr>
+          <a:xfrm>
+            <a:off x="9619488" y="4434840"/>
+            <a:ext cx="384048" cy="0"/>
+          </a:xfrm>
+          <a:prstGeom prst="line">
+            <a:avLst/>
+          </a:prstGeom>
+          <a:ln w="25400">
+            <a:solidFill>
+              <a:srgbClr val="6B7480"/>
+            </a:solidFill>
+            <a:tailEnd type="triangle" w="med" len="med"/>
+          </a:ln>
+          <a:effectLst/>
+        </p:spPr>
+        <p:style>
+          <a:lnRef idx="2">
+            <a:schemeClr val="accent1"/>
+          </a:lnRef>
+          <a:fillRef idx="0">
+            <a:schemeClr val="accent1"/>
+          </a:fillRef>
+          <a:effectRef idx="1">
+            <a:schemeClr val="accent1"/>
+          </a:effectRef>
+          <a:fontRef idx="minor">
+            <a:schemeClr val="tx1"/>
+          </a:fontRef>
+        </p:style>
+      </p:cxnSp>
+      <p:sp>
+        <p:nvSpPr>
+          <p:cNvPr id="25" name="Rounded Rectangle 24"/>
+          <p:cNvSpPr/>
+          <p:nvPr/>
+        </p:nvSpPr>
+        <p:spPr>
+          <a:xfrm>
+            <a:off x="10003536" y="3931920"/>
+            <a:ext cx="1975104" cy="1005840"/>
+          </a:xfrm>
+          <a:prstGeom prst="roundRect">
+            <a:avLst>
+              <a:gd name="adj" fmla="val 12000"/>
+            </a:avLst>
+          </a:prstGeom>
+          <a:solidFill>
+            <a:srgbClr val="2E7D4F"/>
+          </a:solidFill>
+          <a:ln>
+            <a:noFill/>
+          </a:ln>
+          <a:effectLst/>
+        </p:spPr>
+        <p:style>
+          <a:lnRef idx="1">
+            <a:schemeClr val="accent1"/>
+          </a:lnRef>
+          <a:fillRef idx="3">
+            <a:schemeClr val="accent1"/>
+          </a:fillRef>
+          <a:effectRef idx="2">
+            <a:schemeClr val="accent1"/>
+          </a:effectRef>
+          <a:fontRef idx="minor">
+            <a:schemeClr val="lt1"/>
+          </a:fontRef>
+        </p:style>
+        <p:txBody>
+          <a:bodyPr rtlCol="0" anchor="ctr" wrap="square" lIns="73152" rIns="73152" tIns="36576" bIns="36576"/>
+          <a:lstStyle/>
+          <a:p>
+            <a:pPr algn="ctr"/>
+            <a:r>
+              <a:rPr sz="1500" b="1">
+                <a:solidFill>
+                  <a:srgbClr val="FFFFFF"/>
+                </a:solidFill>
+                <a:latin typeface="微软雅黑"/>
+                <a:ea typeface="微软雅黑"/>
+              </a:rPr>
+              <a:t>导出 Lean</a:t>
+            </a:r>
+          </a:p>
+          <a:p>
+            <a:pPr algn="ctr"/>
+            <a:r>
+              <a:rPr sz="1150" b="0">
+                <a:solidFill>
+                  <a:srgbClr val="FFFFFF"/>
+                </a:solidFill>
+                <a:latin typeface="微软雅黑"/>
+                <a:ea typeface="微软雅黑"/>
+              </a:rPr>
               <a:t>def certificate</a:t>
             </a:r>
           </a:p>
@@ -34779,14 +36452,14 @@
       </p:sp>
       <p:sp>
         <p:nvSpPr>
-          <p:cNvPr id="15" name="Rounded Rectangle 14"/>
+          <p:cNvPr id="26" name="Rounded Rectangle 25"/>
           <p:cNvSpPr/>
           <p:nvPr/>
         </p:nvSpPr>
         <p:spPr>
           <a:xfrm>
-            <a:off x="566928" y="3520440"/>
-            <a:ext cx="2679192" cy="621792"/>
+            <a:off x="566928" y="5257800"/>
+            <a:ext cx="2679192" cy="548640"/>
           </a:xfrm>
           <a:prstGeom prst="roundRect">
             <a:avLst>
@@ -34821,7 +36494,7 @@
           <a:p>
             <a:pPr algn="ctr"/>
             <a:r>
-              <a:rPr sz="1400" b="1">
+              <a:rPr sz="1300" b="1">
                 <a:solidFill>
                   <a:srgbClr val="2B2B2B"/>
                 </a:solidFill>
@@ -34835,14 +36508,14 @@
       </p:sp>
       <p:sp>
         <p:nvSpPr>
-          <p:cNvPr id="16" name="Rounded Rectangle 15"/>
+          <p:cNvPr id="27" name="Rounded Rectangle 26"/>
           <p:cNvSpPr/>
           <p:nvPr/>
         </p:nvSpPr>
         <p:spPr>
           <a:xfrm>
-            <a:off x="3429000" y="3520440"/>
-            <a:ext cx="2679192" cy="621792"/>
+            <a:off x="3429000" y="5257800"/>
+            <a:ext cx="2679192" cy="548640"/>
           </a:xfrm>
           <a:prstGeom prst="roundRect">
             <a:avLst>
@@ -34877,7 +36550,7 @@
           <a:p>
             <a:pPr algn="ctr"/>
             <a:r>
-              <a:rPr sz="1400" b="1">
+              <a:rPr sz="1300" b="1">
                 <a:solidFill>
                   <a:srgbClr val="2B2B2B"/>
                 </a:solidFill>
@@ -34891,14 +36564,14 @@
       </p:sp>
       <p:sp>
         <p:nvSpPr>
-          <p:cNvPr id="17" name="Rounded Rectangle 16"/>
+          <p:cNvPr id="28" name="Rounded Rectangle 27"/>
           <p:cNvSpPr/>
           <p:nvPr/>
         </p:nvSpPr>
         <p:spPr>
           <a:xfrm>
-            <a:off x="6291072" y="3520440"/>
-            <a:ext cx="2679192" cy="621792"/>
+            <a:off x="6291072" y="5257800"/>
+            <a:ext cx="2679192" cy="548640"/>
           </a:xfrm>
           <a:prstGeom prst="roundRect">
             <a:avLst>
@@ -34933,7 +36606,7 @@
           <a:p>
             <a:pPr algn="ctr"/>
             <a:r>
-              <a:rPr sz="1400" b="1">
+              <a:rPr sz="1300" b="1">
                 <a:solidFill>
                   <a:srgbClr val="2B2B2B"/>
                 </a:solidFill>
@@ -34947,14 +36620,14 @@
       </p:sp>
       <p:sp>
         <p:nvSpPr>
-          <p:cNvPr id="18" name="Rounded Rectangle 17"/>
+          <p:cNvPr id="29" name="Rounded Rectangle 28"/>
           <p:cNvSpPr/>
           <p:nvPr/>
         </p:nvSpPr>
         <p:spPr>
           <a:xfrm>
-            <a:off x="9153144" y="3520440"/>
-            <a:ext cx="2679192" cy="621792"/>
+            <a:off x="9153144" y="5257800"/>
+            <a:ext cx="2679192" cy="548640"/>
           </a:xfrm>
           <a:prstGeom prst="roundRect">
             <a:avLst>
@@ -34989,7 +36662,7 @@
           <a:p>
             <a:pPr algn="ctr"/>
             <a:r>
-              <a:rPr sz="1400" b="1">
+              <a:rPr sz="1300" b="1">
                 <a:solidFill>
                   <a:srgbClr val="2B2B2B"/>
                 </a:solidFill>
@@ -35003,14 +36676,14 @@
       </p:sp>
       <p:sp>
         <p:nvSpPr>
-          <p:cNvPr id="19" name="Rounded Rectangle 18"/>
+          <p:cNvPr id="30" name="Rounded Rectangle 29"/>
           <p:cNvSpPr/>
           <p:nvPr/>
         </p:nvSpPr>
         <p:spPr>
           <a:xfrm>
-            <a:off x="566928" y="4617720"/>
-            <a:ext cx="11055096" cy="731520"/>
+            <a:off x="566928" y="5989320"/>
+            <a:ext cx="11055096" cy="502920"/>
           </a:xfrm>
           <a:prstGeom prst="roundRect">
             <a:avLst>
@@ -35045,21 +36718,21 @@
           <a:p>
             <a:pPr algn="ctr"/>
             <a:r>
-              <a:rPr sz="1550" b="1">
+              <a:rPr sz="1400" b="1">
                 <a:solidFill>
                   <a:srgbClr val="C98A2D"/>
                 </a:solidFill>
                 <a:latin typeface="微软雅黑"/>
                 <a:ea typeface="微软雅黑"/>
               </a:rPr>
-              <a:t>整条流水线只产生“候选数据”：任何算法、启发式、缓存都不能直接当结论，最终由 Lean 检查器验证。</a:t>
-            </a:r>
-          </a:p>
-        </p:txBody>
-      </p:sp>
-      <p:sp>
-        <p:nvSpPr>
-          <p:cNvPr id="20" name="TextBox 19"/>
+              <a:t>两条流水线都只产生“候选数据”：任何算法、启发式、缓存都不能直接当结论，最终由 Lean 检查器验证。</a:t>
+            </a:r>
+          </a:p>
+        </p:txBody>
+      </p:sp>
+      <p:sp>
+        <p:nvSpPr>
+          <p:cNvPr id="31" name="TextBox 30"/>
           <p:cNvSpPr txBox="1"/>
           <p:nvPr/>
         </p:nvSpPr>
@@ -35095,7 +36768,7 @@
       </p:sp>
       <p:sp>
         <p:nvSpPr>
-          <p:cNvPr id="21" name="TextBox 20"/>
+          <p:cNvPr id="32" name="TextBox 31"/>
           <p:cNvSpPr txBox="1"/>
           <p:nvPr/>
         </p:nvSpPr>

</xml_diff>

<commit_message>
docs: regenerate chapter PPT (28p) with exact remaining-gap wording; scripts updated
</commit_message>
<xml_diff>
--- a/五子棋项目阶段汇报.pptx
+++ b/五子棋项目阶段汇报.pptx
@@ -1789,7 +1789,7 @@
           <a:lstStyle/>
           <a:p>
             <a:r>
-              <a:t>但必须坦率地说，还有明显缺口。第一，空棋盘开局求解没有完成，不能宣称黑棋先手必胜；第二，空棋盘和棋还没有证明，目前只有中盘局面的和棋；第三，缓存已经定义好，但还没接入默认搜索流程；第四，目前只在一步胜、双应手和中盘和棋这些局面上验证过，规模没有跑起来。</a:t>
+              <a:t>但必须坦率地说，还有明显缺口。第一，空棋盘开局求解没有完成，不能宣称黑棋先手必胜；第二，空棋盘和棋其实只差一环：黑防白已经用策略偷取证明了，还缺白防黑，补上就能组合出空棋盘 StandardDraw；第三，缓存已经定义好，但还没接入默认搜索流程；第四，目前只在一步胜、双应手和中盘和棋这些局面上验证过，规模没有跑起来。</a:t>
             </a:r>
           </a:p>
         </p:txBody>
@@ -1929,7 +1929,7 @@
           <a:lstStyle/>
           <a:p>
             <a:r>
-              <a:t>总结：搜索器负责找，Lean 负责证。已经做的是规则、证书检查链、搜索器、示例复检，以及 9 个中盘和棋局面；没有做的是空棋盘开局求解、空棋盘和棋、大规模验证。谢谢大家，欢迎提问。</a:t>
+              <a:t>总结：搜索器负责找，Lean 负责证。已经做的是规则、证书检查链、搜索器、示例复检，以及 9 个中盘和棋局面；没有做的是空棋盘开局求解、空棋盘“白防黑”（只差这一环）和大规模验证。谢谢大家，欢迎提问。</a:t>
             </a:r>
           </a:p>
         </p:txBody>
@@ -30236,7 +30236,7 @@
                 <a:latin typeface="微软雅黑"/>
                 <a:ea typeface="微软雅黑"/>
               </a:rPr>
-              <a:t>空棋盘和棋 · 未完成</a:t>
+              <a:t>空棋盘和棋 · 只差“白防黑”一环</a:t>
             </a:r>
           </a:p>
         </p:txBody>
@@ -30276,7 +30276,7 @@
                 <a:latin typeface="微软雅黑"/>
                 <a:ea typeface="微软雅黑"/>
               </a:rPr>
-              <a:t>中盘 9 局面的和棋已验证；空棋盘 StandardDraw 仍是开放目标</a:t>
+              <a:t>黑防白 BlackCanPreventWhiteWin initialPosition 已证（策略偷取）；只差 WhiteCanPreventBlackWin initialPosition，即可组合出空棋盘 StandardDraw</a:t>
             </a:r>
           </a:p>
         </p:txBody>
@@ -31972,7 +31972,7 @@
                 <a:latin typeface="微软雅黑"/>
                 <a:ea typeface="微软雅黑"/>
               </a:rPr>
-              <a:t>未做：空棋盘开局求解 · 空棋盘和棋 · 大规模验证</a:t>
+              <a:t>未做：空棋盘开局求解 · 空棋盘“白防黑”（只差一环）· 大规模验证</a:t>
             </a:r>
           </a:p>
         </p:txBody>

</xml_diff>